<commit_message>
Design 2 Phase 3
</commit_message>
<xml_diff>
--- a/Section_IV_BioComputing/slides/Designs.pptx
+++ b/Section_IV_BioComputing/slides/Designs.pptx
@@ -114,7 +114,7 @@
   <p:extLst>
     <p:ext uri="{EFAFB233-063F-42B5-8137-9DF3F51BA10A}">
       <p15:sldGuideLst xmlns:p15="http://schemas.microsoft.com/office/powerpoint/2012/main">
-        <p15:guide id="1" orient="horz" pos="2160" userDrawn="1">
+        <p15:guide id="1" orient="horz" pos="1800" userDrawn="1">
           <p15:clr>
             <a:srgbClr val="A4A3A4"/>
           </p15:clr>
@@ -212,7 +212,7 @@
           <a:p>
             <a:fld id="{587CBFC6-A9BB-4E5E-87F9-DC306CACD92F}" type="datetimeFigureOut">
               <a:rPr lang="en-US" smtClean="0"/>
-              <a:t>10/2/2025</a:t>
+              <a:t>10/3/2025</a:t>
             </a:fld>
             <a:endParaRPr lang="en-US"/>
           </a:p>
@@ -950,7 +950,7 @@
           <a:p>
             <a:fld id="{9EFB2E82-6871-4A63-8FC6-B35E58246C01}" type="datetimeFigureOut">
               <a:rPr lang="en-US" smtClean="0"/>
-              <a:t>10/2/2025</a:t>
+              <a:t>10/3/2025</a:t>
             </a:fld>
             <a:endParaRPr lang="en-US"/>
           </a:p>
@@ -1148,7 +1148,7 @@
           <a:p>
             <a:fld id="{9EFB2E82-6871-4A63-8FC6-B35E58246C01}" type="datetimeFigureOut">
               <a:rPr lang="en-US" smtClean="0"/>
-              <a:t>10/2/2025</a:t>
+              <a:t>10/3/2025</a:t>
             </a:fld>
             <a:endParaRPr lang="en-US"/>
           </a:p>
@@ -1356,7 +1356,7 @@
           <a:p>
             <a:fld id="{9EFB2E82-6871-4A63-8FC6-B35E58246C01}" type="datetimeFigureOut">
               <a:rPr lang="en-US" smtClean="0"/>
-              <a:t>10/2/2025</a:t>
+              <a:t>10/3/2025</a:t>
             </a:fld>
             <a:endParaRPr lang="en-US"/>
           </a:p>
@@ -1800,7 +1800,7 @@
           <a:p>
             <a:fld id="{9EFB2E82-6871-4A63-8FC6-B35E58246C01}" type="datetimeFigureOut">
               <a:rPr lang="en-US" smtClean="0"/>
-              <a:t>10/2/2025</a:t>
+              <a:t>10/3/2025</a:t>
             </a:fld>
             <a:endParaRPr lang="en-US"/>
           </a:p>
@@ -2075,7 +2075,7 @@
           <a:p>
             <a:fld id="{9EFB2E82-6871-4A63-8FC6-B35E58246C01}" type="datetimeFigureOut">
               <a:rPr lang="en-US" smtClean="0"/>
-              <a:t>10/2/2025</a:t>
+              <a:t>10/3/2025</a:t>
             </a:fld>
             <a:endParaRPr lang="en-US"/>
           </a:p>
@@ -2340,7 +2340,7 @@
           <a:p>
             <a:fld id="{9EFB2E82-6871-4A63-8FC6-B35E58246C01}" type="datetimeFigureOut">
               <a:rPr lang="en-US" smtClean="0"/>
-              <a:t>10/2/2025</a:t>
+              <a:t>10/3/2025</a:t>
             </a:fld>
             <a:endParaRPr lang="en-US"/>
           </a:p>
@@ -2752,7 +2752,7 @@
           <a:p>
             <a:fld id="{9EFB2E82-6871-4A63-8FC6-B35E58246C01}" type="datetimeFigureOut">
               <a:rPr lang="en-US" smtClean="0"/>
-              <a:t>10/2/2025</a:t>
+              <a:t>10/3/2025</a:t>
             </a:fld>
             <a:endParaRPr lang="en-US"/>
           </a:p>
@@ -2893,7 +2893,7 @@
           <a:p>
             <a:fld id="{9EFB2E82-6871-4A63-8FC6-B35E58246C01}" type="datetimeFigureOut">
               <a:rPr lang="en-US" smtClean="0"/>
-              <a:t>10/2/2025</a:t>
+              <a:t>10/3/2025</a:t>
             </a:fld>
             <a:endParaRPr lang="en-US"/>
           </a:p>
@@ -3006,7 +3006,7 @@
           <a:p>
             <a:fld id="{9EFB2E82-6871-4A63-8FC6-B35E58246C01}" type="datetimeFigureOut">
               <a:rPr lang="en-US" smtClean="0"/>
-              <a:t>10/2/2025</a:t>
+              <a:t>10/3/2025</a:t>
             </a:fld>
             <a:endParaRPr lang="en-US"/>
           </a:p>
@@ -3317,7 +3317,7 @@
           <a:p>
             <a:fld id="{9EFB2E82-6871-4A63-8FC6-B35E58246C01}" type="datetimeFigureOut">
               <a:rPr lang="en-US" smtClean="0"/>
-              <a:t>10/2/2025</a:t>
+              <a:t>10/3/2025</a:t>
             </a:fld>
             <a:endParaRPr lang="en-US"/>
           </a:p>
@@ -3605,7 +3605,7 @@
           <a:p>
             <a:fld id="{9EFB2E82-6871-4A63-8FC6-B35E58246C01}" type="datetimeFigureOut">
               <a:rPr lang="en-US" smtClean="0"/>
-              <a:t>10/2/2025</a:t>
+              <a:t>10/3/2025</a:t>
             </a:fld>
             <a:endParaRPr lang="en-US"/>
           </a:p>
@@ -3846,7 +3846,7 @@
           <a:p>
             <a:fld id="{9EFB2E82-6871-4A63-8FC6-B35E58246C01}" type="datetimeFigureOut">
               <a:rPr lang="en-US" smtClean="0"/>
-              <a:t>10/2/2025</a:t>
+              <a:t>10/3/2025</a:t>
             </a:fld>
             <a:endParaRPr lang="en-US"/>
           </a:p>
@@ -13467,7 +13467,7 @@
           <a:lstStyle/>
           <a:p>
             <a:pPr algn="ctr"/>
-            <a:endParaRPr lang="en-GB"/>
+            <a:endParaRPr lang="en-GB" sz="2000"/>
           </a:p>
         </p:txBody>
       </p:sp>
@@ -13501,7 +13501,7 @@
           <a:p>
             <a:pPr algn="r"/>
             <a:r>
-              <a:rPr lang="en-GB" sz="3600" dirty="0">
+              <a:rPr lang="en-GB" sz="2000" dirty="0">
                 <a:solidFill>
                   <a:schemeClr val="tx1"/>
                 </a:solidFill>
@@ -13528,7 +13528,7 @@
             <p:spPr>
               <a:xfrm>
                 <a:off x="951250" y="3209314"/>
-                <a:ext cx="766877" cy="523220"/>
+                <a:ext cx="600549" cy="400110"/>
               </a:xfrm>
               <a:prstGeom prst="rect">
                 <a:avLst/>
@@ -13551,14 +13551,14 @@
                       <m:sSub>
                         <m:sSubPr>
                           <m:ctrlPr>
-                            <a:rPr lang="en-US" sz="2800" i="1" smtClean="0">
+                            <a:rPr lang="en-US" sz="2000" i="1" smtClean="0">
                               <a:latin typeface="Cambria Math" panose="02040503050406030204" pitchFamily="18" charset="0"/>
                             </a:rPr>
                           </m:ctrlPr>
                         </m:sSubPr>
                         <m:e>
                           <m:r>
-                            <a:rPr lang="en-US" sz="2800" b="0" i="1" smtClean="0">
+                            <a:rPr lang="en-US" sz="2000" b="0" i="1" smtClean="0">
                               <a:latin typeface="Cambria Math" panose="02040503050406030204" pitchFamily="18" charset="0"/>
                             </a:rPr>
                             <m:t>𝑃</m:t>
@@ -13566,13 +13566,13 @@
                         </m:e>
                         <m:sub>
                           <m:r>
-                            <a:rPr lang="en-US" sz="2800" b="0" i="1" smtClean="0">
+                            <a:rPr lang="en-US" sz="2000" b="0" i="1" smtClean="0">
                               <a:latin typeface="Cambria Math" panose="02040503050406030204" pitchFamily="18" charset="0"/>
                             </a:rPr>
                             <m:t>𝑏</m:t>
                           </m:r>
                           <m:r>
-                            <a:rPr lang="en-US" sz="2800" b="0" i="1" smtClean="0">
+                            <a:rPr lang="en-US" sz="2000" b="0" i="1" smtClean="0">
                               <a:latin typeface="Cambria Math" panose="02040503050406030204" pitchFamily="18" charset="0"/>
                             </a:rPr>
                             <m:t>0</m:t>
@@ -13582,7 +13582,7 @@
                     </m:oMath>
                   </m:oMathPara>
                 </a14:m>
-                <a:endParaRPr lang="en-US" sz="2800" dirty="0"/>
+                <a:endParaRPr lang="en-US" sz="2000" dirty="0"/>
               </a:p>
             </p:txBody>
           </p:sp>
@@ -13605,7 +13605,7 @@
             <p:spPr>
               <a:xfrm>
                 <a:off x="951250" y="3209314"/>
-                <a:ext cx="766877" cy="523220"/>
+                <a:ext cx="600549" cy="400110"/>
               </a:xfrm>
               <a:prstGeom prst="rect">
                 <a:avLst/>
@@ -13649,7 +13649,7 @@
             <p:spPr>
               <a:xfrm>
                 <a:off x="1124521" y="1935376"/>
-                <a:ext cx="779701" cy="523220"/>
+                <a:ext cx="610167" cy="400110"/>
               </a:xfrm>
               <a:prstGeom prst="rect">
                 <a:avLst/>
@@ -13672,14 +13672,14 @@
                       <m:sSub>
                         <m:sSubPr>
                           <m:ctrlPr>
-                            <a:rPr lang="en-US" sz="2800" i="1" smtClean="0">
+                            <a:rPr lang="en-US" sz="2000" i="1" smtClean="0">
                               <a:latin typeface="Cambria Math" panose="02040503050406030204" pitchFamily="18" charset="0"/>
                             </a:rPr>
                           </m:ctrlPr>
                         </m:sSubPr>
                         <m:e>
                           <m:r>
-                            <a:rPr lang="en-US" sz="2800" b="0" i="1" smtClean="0">
+                            <a:rPr lang="en-US" sz="2000" b="0" i="1" smtClean="0">
                               <a:latin typeface="Cambria Math" panose="02040503050406030204" pitchFamily="18" charset="0"/>
                             </a:rPr>
                             <m:t>𝑃</m:t>
@@ -13687,13 +13687,13 @@
                         </m:e>
                         <m:sub>
                           <m:r>
-                            <a:rPr lang="en-US" sz="2800" b="0" i="1" smtClean="0">
+                            <a:rPr lang="en-US" sz="2000" b="0" i="1" smtClean="0">
                               <a:latin typeface="Cambria Math" panose="02040503050406030204" pitchFamily="18" charset="0"/>
                             </a:rPr>
                             <m:t>𝑢</m:t>
                           </m:r>
                           <m:r>
-                            <a:rPr lang="en-US" sz="2800" b="0" i="1" smtClean="0">
+                            <a:rPr lang="en-US" sz="2000" b="0" i="1" smtClean="0">
                               <a:latin typeface="Cambria Math" panose="02040503050406030204" pitchFamily="18" charset="0"/>
                             </a:rPr>
                             <m:t>0</m:t>
@@ -13703,7 +13703,7 @@
                     </m:oMath>
                   </m:oMathPara>
                 </a14:m>
-                <a:endParaRPr lang="en-US" sz="2800" dirty="0"/>
+                <a:endParaRPr lang="en-US" sz="2000" dirty="0"/>
               </a:p>
             </p:txBody>
           </p:sp>
@@ -13726,7 +13726,7 @@
             <p:spPr>
               <a:xfrm>
                 <a:off x="1124521" y="1935376"/>
-                <a:ext cx="779701" cy="523220"/>
+                <a:ext cx="610167" cy="400110"/>
               </a:xfrm>
               <a:prstGeom prst="rect">
                 <a:avLst/>
@@ -13770,8 +13770,8 @@
         </p:nvCxnSpPr>
         <p:spPr>
           <a:xfrm>
-            <a:off x="1514372" y="2458596"/>
-            <a:ext cx="218303" cy="281573"/>
+            <a:off x="1429605" y="2335486"/>
+            <a:ext cx="303070" cy="404683"/>
           </a:xfrm>
           <a:prstGeom prst="straightConnector1">
             <a:avLst/>
@@ -13852,8 +13852,8 @@
             </p:nvSpPr>
             <p:spPr>
               <a:xfrm>
-                <a:off x="9445659" y="1771015"/>
-                <a:ext cx="931986" cy="523220"/>
+                <a:off x="9786722" y="2122036"/>
+                <a:ext cx="719171" cy="400110"/>
               </a:xfrm>
               <a:prstGeom prst="rect">
                 <a:avLst/>
@@ -13876,14 +13876,14 @@
                       <m:sSub>
                         <m:sSubPr>
                           <m:ctrlPr>
-                            <a:rPr lang="en-US" sz="2800" i="1" smtClean="0">
+                            <a:rPr lang="en-US" sz="2000" i="1" smtClean="0">
                               <a:latin typeface="Cambria Math" panose="02040503050406030204" pitchFamily="18" charset="0"/>
                             </a:rPr>
                           </m:ctrlPr>
                         </m:sSubPr>
                         <m:e>
                           <m:r>
-                            <a:rPr lang="en-US" sz="2800" b="0" i="1" smtClean="0">
+                            <a:rPr lang="en-US" sz="2000" b="0" i="1" smtClean="0">
                               <a:latin typeface="Cambria Math" panose="02040503050406030204" pitchFamily="18" charset="0"/>
                             </a:rPr>
                             <m:t>𝑃</m:t>
@@ -13891,13 +13891,13 @@
                         </m:e>
                         <m:sub>
                           <m:r>
-                            <a:rPr lang="en-US" sz="2800" b="0" i="1" smtClean="0">
+                            <a:rPr lang="en-US" sz="2000" b="0" i="1" smtClean="0">
                               <a:latin typeface="Cambria Math" panose="02040503050406030204" pitchFamily="18" charset="0"/>
                             </a:rPr>
                             <m:t>𝑢</m:t>
                           </m:r>
                           <m:r>
-                            <a:rPr lang="de-DE" sz="2800" b="0" i="1" smtClean="0">
+                            <a:rPr lang="de-DE" sz="2000" b="0" i="1" smtClean="0">
                               <a:latin typeface="Cambria Math" panose="02040503050406030204" pitchFamily="18" charset="0"/>
                             </a:rPr>
                             <m:t>22</m:t>
@@ -13907,7 +13907,7 @@
                     </m:oMath>
                   </m:oMathPara>
                 </a14:m>
-                <a:endParaRPr lang="en-US" sz="2800" dirty="0"/>
+                <a:endParaRPr lang="en-US" sz="2000" dirty="0"/>
               </a:p>
             </p:txBody>
           </p:sp>
@@ -13929,8 +13929,8 @@
             </p:nvSpPr>
             <p:spPr>
               <a:xfrm>
-                <a:off x="9445659" y="1771015"/>
-                <a:ext cx="931986" cy="523220"/>
+                <a:off x="9786722" y="2122036"/>
+                <a:ext cx="719171" cy="400110"/>
               </a:xfrm>
               <a:prstGeom prst="rect">
                 <a:avLst/>
@@ -13973,8 +13973,8 @@
         </p:nvCxnSpPr>
         <p:spPr>
           <a:xfrm flipH="1">
-            <a:off x="9538931" y="2363628"/>
-            <a:ext cx="3464" cy="419531"/>
+            <a:off x="9974476" y="2566501"/>
+            <a:ext cx="95426" cy="461206"/>
           </a:xfrm>
           <a:prstGeom prst="straightConnector1">
             <a:avLst/>
@@ -14014,8 +14014,8 @@
             </p:nvSpPr>
             <p:spPr>
               <a:xfrm>
-                <a:off x="9670719" y="3407614"/>
-                <a:ext cx="931986" cy="523220"/>
+                <a:off x="9661194" y="3540964"/>
+                <a:ext cx="719171" cy="400110"/>
               </a:xfrm>
               <a:prstGeom prst="rect">
                 <a:avLst/>
@@ -14038,14 +14038,14 @@
                       <m:sSub>
                         <m:sSubPr>
                           <m:ctrlPr>
-                            <a:rPr lang="en-US" sz="2800" i="1" smtClean="0">
+                            <a:rPr lang="en-US" sz="2000" i="1" smtClean="0">
                               <a:latin typeface="Cambria Math" panose="02040503050406030204" pitchFamily="18" charset="0"/>
                             </a:rPr>
                           </m:ctrlPr>
                         </m:sSubPr>
                         <m:e>
                           <m:r>
-                            <a:rPr lang="en-US" sz="2800" b="0" i="1" smtClean="0">
+                            <a:rPr lang="en-US" sz="2000" b="0" i="1" smtClean="0">
                               <a:latin typeface="Cambria Math" panose="02040503050406030204" pitchFamily="18" charset="0"/>
                             </a:rPr>
                             <m:t>𝑃</m:t>
@@ -14053,13 +14053,13 @@
                         </m:e>
                         <m:sub>
                           <m:r>
-                            <a:rPr lang="de-DE" sz="2800" b="0" i="1" smtClean="0">
+                            <a:rPr lang="de-DE" sz="2000" b="0" i="1" smtClean="0">
                               <a:latin typeface="Cambria Math" panose="02040503050406030204" pitchFamily="18" charset="0"/>
                             </a:rPr>
                             <m:t>𝑢</m:t>
                           </m:r>
                           <m:r>
-                            <a:rPr lang="de-DE" sz="2800" b="0" i="1" smtClean="0">
+                            <a:rPr lang="de-DE" sz="2000" b="0" i="1" smtClean="0">
                               <a:latin typeface="Cambria Math" panose="02040503050406030204" pitchFamily="18" charset="0"/>
                             </a:rPr>
                             <m:t>32</m:t>
@@ -14069,7 +14069,7 @@
                     </m:oMath>
                   </m:oMathPara>
                 </a14:m>
-                <a:endParaRPr lang="en-US" sz="2800" dirty="0"/>
+                <a:endParaRPr lang="en-US" sz="2000" dirty="0"/>
               </a:p>
             </p:txBody>
           </p:sp>
@@ -14091,8 +14091,8 @@
             </p:nvSpPr>
             <p:spPr>
               <a:xfrm>
-                <a:off x="9670719" y="3407614"/>
-                <a:ext cx="931986" cy="523220"/>
+                <a:off x="9661194" y="3540964"/>
+                <a:ext cx="719171" cy="400110"/>
               </a:xfrm>
               <a:prstGeom prst="rect">
                 <a:avLst/>
@@ -14136,7 +14136,7 @@
             <p:spPr>
               <a:xfrm>
                 <a:off x="3387959" y="2104385"/>
-                <a:ext cx="919162" cy="523220"/>
+                <a:ext cx="709553" cy="400110"/>
               </a:xfrm>
               <a:prstGeom prst="rect">
                 <a:avLst/>
@@ -14159,14 +14159,14 @@
                       <m:sSub>
                         <m:sSubPr>
                           <m:ctrlPr>
-                            <a:rPr lang="en-US" sz="2800" i="1" smtClean="0">
+                            <a:rPr lang="en-US" sz="2000" i="1" smtClean="0">
                               <a:latin typeface="Cambria Math" panose="02040503050406030204" pitchFamily="18" charset="0"/>
                             </a:rPr>
                           </m:ctrlPr>
                         </m:sSubPr>
                         <m:e>
                           <m:r>
-                            <a:rPr lang="en-US" sz="2800" b="0" i="1" smtClean="0">
+                            <a:rPr lang="en-US" sz="2000" b="0" i="1" smtClean="0">
                               <a:latin typeface="Cambria Math" panose="02040503050406030204" pitchFamily="18" charset="0"/>
                             </a:rPr>
                             <m:t>𝑃</m:t>
@@ -14174,19 +14174,19 @@
                         </m:e>
                         <m:sub>
                           <m:r>
-                            <a:rPr lang="en-US" sz="2800" b="0" i="1" smtClean="0">
+                            <a:rPr lang="en-US" sz="2000" b="0" i="1" smtClean="0">
                               <a:latin typeface="Cambria Math" panose="02040503050406030204" pitchFamily="18" charset="0"/>
                             </a:rPr>
                             <m:t>𝑏</m:t>
                           </m:r>
                           <m:r>
-                            <a:rPr lang="de-DE" sz="2800" b="0" i="1" smtClean="0">
+                            <a:rPr lang="de-DE" sz="2000" b="0" i="1" smtClean="0">
                               <a:latin typeface="Cambria Math" panose="02040503050406030204" pitchFamily="18" charset="0"/>
                             </a:rPr>
                             <m:t>2</m:t>
                           </m:r>
                           <m:r>
-                            <a:rPr lang="en-US" sz="2800" b="0" i="1" smtClean="0">
+                            <a:rPr lang="en-US" sz="2000" b="0" i="1" smtClean="0">
                               <a:latin typeface="Cambria Math" panose="02040503050406030204" pitchFamily="18" charset="0"/>
                             </a:rPr>
                             <m:t>1</m:t>
@@ -14196,7 +14196,7 @@
                     </m:oMath>
                   </m:oMathPara>
                 </a14:m>
-                <a:endParaRPr lang="en-US" sz="2800" dirty="0"/>
+                <a:endParaRPr lang="en-US" sz="2000" dirty="0"/>
               </a:p>
             </p:txBody>
           </p:sp>
@@ -14219,7 +14219,7 @@
             <p:spPr>
               <a:xfrm>
                 <a:off x="3387959" y="2104385"/>
-                <a:ext cx="919162" cy="523220"/>
+                <a:ext cx="709553" cy="400110"/>
               </a:xfrm>
               <a:prstGeom prst="rect">
                 <a:avLst/>
@@ -14263,7 +14263,7 @@
             <p:spPr>
               <a:xfrm>
                 <a:off x="3353568" y="3202828"/>
-                <a:ext cx="919162" cy="523220"/>
+                <a:ext cx="709553" cy="400110"/>
               </a:xfrm>
               <a:prstGeom prst="rect">
                 <a:avLst/>
@@ -14286,14 +14286,14 @@
                       <m:sSub>
                         <m:sSubPr>
                           <m:ctrlPr>
-                            <a:rPr lang="en-US" sz="2800" i="1" smtClean="0">
+                            <a:rPr lang="en-US" sz="2000" i="1" smtClean="0">
                               <a:latin typeface="Cambria Math" panose="02040503050406030204" pitchFamily="18" charset="0"/>
                             </a:rPr>
                           </m:ctrlPr>
                         </m:sSubPr>
                         <m:e>
                           <m:r>
-                            <a:rPr lang="en-US" sz="2800" b="0" i="1" smtClean="0">
+                            <a:rPr lang="en-US" sz="2000" b="0" i="1" smtClean="0">
                               <a:latin typeface="Cambria Math" panose="02040503050406030204" pitchFamily="18" charset="0"/>
                             </a:rPr>
                             <m:t>𝑃</m:t>
@@ -14301,13 +14301,13 @@
                         </m:e>
                         <m:sub>
                           <m:r>
-                            <a:rPr lang="de-DE" sz="2800" b="0" i="1" smtClean="0">
+                            <a:rPr lang="de-DE" sz="2000" b="0" i="1" smtClean="0">
                               <a:latin typeface="Cambria Math" panose="02040503050406030204" pitchFamily="18" charset="0"/>
                             </a:rPr>
                             <m:t>𝑏</m:t>
                           </m:r>
                           <m:r>
-                            <a:rPr lang="de-DE" sz="2800" b="0" i="1" smtClean="0">
+                            <a:rPr lang="de-DE" sz="2000" b="0" i="1" smtClean="0">
                               <a:latin typeface="Cambria Math" panose="02040503050406030204" pitchFamily="18" charset="0"/>
                             </a:rPr>
                             <m:t>31</m:t>
@@ -14317,7 +14317,7 @@
                     </m:oMath>
                   </m:oMathPara>
                 </a14:m>
-                <a:endParaRPr lang="en-US" sz="2800" dirty="0"/>
+                <a:endParaRPr lang="en-US" sz="2000" dirty="0"/>
               </a:p>
             </p:txBody>
           </p:sp>
@@ -14340,7 +14340,7 @@
             <p:spPr>
               <a:xfrm>
                 <a:off x="3353568" y="3202828"/>
-                <a:ext cx="919162" cy="523220"/>
+                <a:ext cx="709553" cy="400110"/>
               </a:xfrm>
               <a:prstGeom prst="rect">
                 <a:avLst/>
@@ -14383,8 +14383,8 @@
             </p:nvSpPr>
             <p:spPr>
               <a:xfrm>
-                <a:off x="5550729" y="11231"/>
-                <a:ext cx="931986" cy="523220"/>
+                <a:off x="5634278" y="31303"/>
+                <a:ext cx="719171" cy="400110"/>
               </a:xfrm>
               <a:prstGeom prst="rect">
                 <a:avLst/>
@@ -14407,14 +14407,14 @@
                       <m:sSub>
                         <m:sSubPr>
                           <m:ctrlPr>
-                            <a:rPr lang="en-US" sz="2800" i="1" smtClean="0">
+                            <a:rPr lang="en-US" sz="2000" i="1" smtClean="0">
                               <a:latin typeface="Cambria Math" panose="02040503050406030204" pitchFamily="18" charset="0"/>
                             </a:rPr>
                           </m:ctrlPr>
                         </m:sSubPr>
                         <m:e>
                           <m:r>
-                            <a:rPr lang="en-US" sz="2800" b="0" i="1" smtClean="0">
+                            <a:rPr lang="en-US" sz="2000" b="0" i="1" smtClean="0">
                               <a:latin typeface="Cambria Math" panose="02040503050406030204" pitchFamily="18" charset="0"/>
                             </a:rPr>
                             <m:t>𝑃</m:t>
@@ -14422,13 +14422,13 @@
                         </m:e>
                         <m:sub>
                           <m:r>
-                            <a:rPr lang="de-DE" sz="2800" b="0" i="1" smtClean="0">
+                            <a:rPr lang="de-DE" sz="2000" b="0" i="1" smtClean="0">
                               <a:latin typeface="Cambria Math" panose="02040503050406030204" pitchFamily="18" charset="0"/>
                             </a:rPr>
                             <m:t>𝑢</m:t>
                           </m:r>
                           <m:r>
-                            <a:rPr lang="de-DE" sz="2800" b="0" i="1" smtClean="0">
+                            <a:rPr lang="de-DE" sz="2000" b="0" i="1" smtClean="0">
                               <a:latin typeface="Cambria Math" panose="02040503050406030204" pitchFamily="18" charset="0"/>
                             </a:rPr>
                             <m:t>21</m:t>
@@ -14438,7 +14438,7 @@
                     </m:oMath>
                   </m:oMathPara>
                 </a14:m>
-                <a:endParaRPr lang="en-US" sz="2800" dirty="0"/>
+                <a:endParaRPr lang="en-US" sz="2000" dirty="0"/>
               </a:p>
             </p:txBody>
           </p:sp>
@@ -14460,8 +14460,8 @@
             </p:nvSpPr>
             <p:spPr>
               <a:xfrm>
-                <a:off x="5550729" y="11231"/>
-                <a:ext cx="931986" cy="523220"/>
+                <a:off x="5634278" y="31303"/>
+                <a:ext cx="719171" cy="400110"/>
               </a:xfrm>
               <a:prstGeom prst="rect">
                 <a:avLst/>
@@ -14503,9 +14503,9 @@
         <p:grpSpPr>
           <a:xfrm>
             <a:off x="3452487" y="2663969"/>
-            <a:ext cx="1255894" cy="523220"/>
+            <a:ext cx="1255894" cy="400110"/>
             <a:chOff x="5372824" y="4174268"/>
-            <a:chExt cx="734184" cy="523220"/>
+            <a:chExt cx="734184" cy="400110"/>
           </a:xfrm>
         </p:grpSpPr>
         <p:sp>
@@ -14558,7 +14558,7 @@
             <a:lstStyle/>
             <a:p>
               <a:pPr algn="ctr"/>
-              <a:endParaRPr lang="en-US" sz="2800" b="1"/>
+              <a:endParaRPr lang="en-US" sz="2000" b="1"/>
             </a:p>
           </p:txBody>
         </p:sp>
@@ -14579,7 +14579,7 @@
               <p:spPr>
                 <a:xfrm>
                   <a:off x="5372824" y="4174268"/>
-                  <a:ext cx="734184" cy="523220"/>
+                  <a:ext cx="734184" cy="400110"/>
                 </a:xfrm>
                 <a:prstGeom prst="rect">
                   <a:avLst/>
@@ -14594,20 +14594,20 @@
                 <a:p>
                   <a:pPr algn="ctr"/>
                   <a:r>
-                    <a:rPr lang="en-US" sz="2800" b="1" dirty="0"/>
+                    <a:rPr lang="en-US" sz="2000" b="1" dirty="0"/>
                     <a:t>Pipe </a:t>
                   </a:r>
                   <a14:m>
                     <m:oMath xmlns:m="http://schemas.openxmlformats.org/officeDocument/2006/math">
                       <m:r>
-                        <a:rPr lang="en-US" sz="2800" b="1" i="1" dirty="0" smtClean="0">
+                        <a:rPr lang="en-US" sz="2000" b="1" i="1" dirty="0" smtClean="0">
                           <a:latin typeface="Cambria Math" panose="02040503050406030204" pitchFamily="18" charset="0"/>
                         </a:rPr>
                         <m:t>𝟏</m:t>
                       </m:r>
                     </m:oMath>
                   </a14:m>
-                  <a:endParaRPr lang="en-DE" sz="2800" b="1" dirty="0"/>
+                  <a:endParaRPr lang="en-DE" sz="2000" b="1" dirty="0"/>
                 </a:p>
               </p:txBody>
             </p:sp>
@@ -14630,7 +14630,7 @@
               <p:spPr>
                 <a:xfrm>
                   <a:off x="5372824" y="4174268"/>
-                  <a:ext cx="734184" cy="523220"/>
+                  <a:ext cx="734184" cy="400110"/>
                 </a:xfrm>
                 <a:prstGeom prst="rect">
                   <a:avLst/>
@@ -14638,7 +14638,7 @@
                 <a:blipFill>
                   <a:blip r:embed="rId10"/>
                   <a:stretch>
-                    <a:fillRect l="-7282" t="-11628" b="-31395"/>
+                    <a:fillRect t="-6061" b="-27273"/>
                   </a:stretch>
                 </a:blipFill>
               </p:spPr>
@@ -14674,8 +14674,8 @@
             </p:nvSpPr>
             <p:spPr>
               <a:xfrm>
-                <a:off x="5832379" y="5428549"/>
-                <a:ext cx="931986" cy="523220"/>
+                <a:off x="5376829" y="5665741"/>
+                <a:ext cx="719171" cy="400110"/>
               </a:xfrm>
               <a:prstGeom prst="rect">
                 <a:avLst/>
@@ -14698,14 +14698,14 @@
                       <m:sSub>
                         <m:sSubPr>
                           <m:ctrlPr>
-                            <a:rPr lang="en-US" sz="2800" i="1" smtClean="0">
+                            <a:rPr lang="en-US" sz="2000" i="1" smtClean="0">
                               <a:latin typeface="Cambria Math" panose="02040503050406030204" pitchFamily="18" charset="0"/>
                             </a:rPr>
                           </m:ctrlPr>
                         </m:sSubPr>
                         <m:e>
                           <m:r>
-                            <a:rPr lang="en-US" sz="2800" b="0" i="1" smtClean="0">
+                            <a:rPr lang="en-US" sz="2000" b="0" i="1" smtClean="0">
                               <a:latin typeface="Cambria Math" panose="02040503050406030204" pitchFamily="18" charset="0"/>
                             </a:rPr>
                             <m:t>𝑃</m:t>
@@ -14713,13 +14713,13 @@
                         </m:e>
                         <m:sub>
                           <m:r>
-                            <a:rPr lang="en-US" sz="2800" b="0" i="1" smtClean="0">
+                            <a:rPr lang="en-US" sz="2000" b="0" i="1" smtClean="0">
                               <a:latin typeface="Cambria Math" panose="02040503050406030204" pitchFamily="18" charset="0"/>
                             </a:rPr>
                             <m:t>𝑢</m:t>
                           </m:r>
                           <m:r>
-                            <a:rPr lang="de-DE" sz="2800" b="0" i="1" smtClean="0">
+                            <a:rPr lang="de-DE" sz="2000" b="0" i="1" smtClean="0">
                               <a:latin typeface="Cambria Math" panose="02040503050406030204" pitchFamily="18" charset="0"/>
                             </a:rPr>
                             <m:t>31</m:t>
@@ -14729,7 +14729,7 @@
                     </m:oMath>
                   </m:oMathPara>
                 </a14:m>
-                <a:endParaRPr lang="en-US" sz="2800" dirty="0"/>
+                <a:endParaRPr lang="en-US" sz="2000" dirty="0"/>
               </a:p>
             </p:txBody>
           </p:sp>
@@ -14751,8 +14751,8 @@
             </p:nvSpPr>
             <p:spPr>
               <a:xfrm>
-                <a:off x="5832379" y="5428549"/>
-                <a:ext cx="931986" cy="523220"/>
+                <a:off x="5376829" y="5665741"/>
+                <a:ext cx="719171" cy="400110"/>
               </a:xfrm>
               <a:prstGeom prst="rect">
                 <a:avLst/>
@@ -14795,8 +14795,8 @@
             </p:nvSpPr>
             <p:spPr>
               <a:xfrm>
-                <a:off x="5529546" y="992204"/>
-                <a:ext cx="919162" cy="523220"/>
+                <a:off x="5626579" y="970670"/>
+                <a:ext cx="709553" cy="400110"/>
               </a:xfrm>
               <a:prstGeom prst="rect">
                 <a:avLst/>
@@ -14819,14 +14819,14 @@
                       <m:sSub>
                         <m:sSubPr>
                           <m:ctrlPr>
-                            <a:rPr lang="en-US" sz="2800" i="1" smtClean="0">
+                            <a:rPr lang="en-US" sz="2000" i="1" smtClean="0">
                               <a:latin typeface="Cambria Math" panose="02040503050406030204" pitchFamily="18" charset="0"/>
                             </a:rPr>
                           </m:ctrlPr>
                         </m:sSubPr>
                         <m:e>
                           <m:r>
-                            <a:rPr lang="en-US" sz="2800" b="0" i="1" smtClean="0">
+                            <a:rPr lang="en-US" sz="2000" b="0" i="1" smtClean="0">
                               <a:latin typeface="Cambria Math" panose="02040503050406030204" pitchFamily="18" charset="0"/>
                             </a:rPr>
                             <m:t>𝑃</m:t>
@@ -14834,13 +14834,13 @@
                         </m:e>
                         <m:sub>
                           <m:r>
-                            <a:rPr lang="en-US" sz="2800" b="0" i="1" smtClean="0">
+                            <a:rPr lang="en-US" sz="2000" b="0" i="1" smtClean="0">
                               <a:latin typeface="Cambria Math" panose="02040503050406030204" pitchFamily="18" charset="0"/>
                             </a:rPr>
                             <m:t>𝑏</m:t>
                           </m:r>
                           <m:r>
-                            <a:rPr lang="en-US" sz="2800" b="0" i="1" smtClean="0">
+                            <a:rPr lang="en-US" sz="2000" b="0" i="1" smtClean="0">
                               <a:latin typeface="Cambria Math" panose="02040503050406030204" pitchFamily="18" charset="0"/>
                             </a:rPr>
                             <m:t>22</m:t>
@@ -14850,7 +14850,7 @@
                     </m:oMath>
                   </m:oMathPara>
                 </a14:m>
-                <a:endParaRPr lang="en-US" sz="2800" dirty="0"/>
+                <a:endParaRPr lang="en-US" sz="2000" dirty="0"/>
               </a:p>
             </p:txBody>
           </p:sp>
@@ -14872,8 +14872,8 @@
             </p:nvSpPr>
             <p:spPr>
               <a:xfrm>
-                <a:off x="5529546" y="992204"/>
-                <a:ext cx="919162" cy="523220"/>
+                <a:off x="5626579" y="970670"/>
+                <a:ext cx="709553" cy="400110"/>
               </a:xfrm>
               <a:prstGeom prst="rect">
                 <a:avLst/>
@@ -15069,7 +15069,7 @@
         <p:spPr>
           <a:xfrm>
             <a:off x="2756613" y="2637118"/>
-            <a:ext cx="5970454" cy="13033"/>
+            <a:ext cx="2925762" cy="13033"/>
           </a:xfrm>
           <a:prstGeom prst="line">
             <a:avLst/>
@@ -15107,7 +15107,7 @@
         <p:spPr>
           <a:xfrm>
             <a:off x="2590527" y="3157668"/>
-            <a:ext cx="6136540" cy="32849"/>
+            <a:ext cx="3083829" cy="0"/>
           </a:xfrm>
           <a:prstGeom prst="line">
             <a:avLst/>
@@ -15221,7 +15221,7 @@
         <p:spPr>
           <a:xfrm>
             <a:off x="5983478" y="913400"/>
-            <a:ext cx="2743589" cy="1720675"/>
+            <a:ext cx="3139696" cy="2004998"/>
           </a:xfrm>
           <a:prstGeom prst="line">
             <a:avLst/>
@@ -15259,7 +15259,7 @@
         <p:spPr>
           <a:xfrm>
             <a:off x="5983406" y="533778"/>
-            <a:ext cx="3566390" cy="2318774"/>
+            <a:ext cx="3917298" cy="2513442"/>
           </a:xfrm>
           <a:prstGeom prst="line">
             <a:avLst/>
@@ -15296,8 +15296,8 @@
         </p:nvCxnSpPr>
         <p:spPr>
           <a:xfrm flipV="1">
-            <a:off x="5682375" y="3202828"/>
-            <a:ext cx="3044692" cy="1971475"/>
+            <a:off x="5682375" y="3441279"/>
+            <a:ext cx="2706226" cy="1733024"/>
           </a:xfrm>
           <a:prstGeom prst="line">
             <a:avLst/>
@@ -15334,8 +15334,8 @@
         </p:nvCxnSpPr>
         <p:spPr>
           <a:xfrm flipV="1">
-            <a:off x="5699670" y="3033140"/>
-            <a:ext cx="3850126" cy="2564451"/>
+            <a:off x="5699670" y="3215897"/>
+            <a:ext cx="3669108" cy="2381694"/>
           </a:xfrm>
           <a:prstGeom prst="line">
             <a:avLst/>
@@ -15371,9 +15371,9 @@
         <p:grpSpPr>
           <a:xfrm>
             <a:off x="3715655" y="724337"/>
-            <a:ext cx="1255894" cy="523220"/>
+            <a:ext cx="1255894" cy="400110"/>
             <a:chOff x="5372824" y="4250468"/>
-            <a:chExt cx="734184" cy="523220"/>
+            <a:chExt cx="734184" cy="400110"/>
           </a:xfrm>
         </p:grpSpPr>
         <p:sp>
@@ -15426,7 +15426,7 @@
             <a:lstStyle/>
             <a:p>
               <a:pPr algn="ctr"/>
-              <a:endParaRPr lang="en-US" sz="2800" b="1"/>
+              <a:endParaRPr lang="en-US" sz="2000" b="1"/>
             </a:p>
           </p:txBody>
         </p:sp>
@@ -15447,7 +15447,7 @@
               <p:spPr>
                 <a:xfrm>
                   <a:off x="5372824" y="4250468"/>
-                  <a:ext cx="734184" cy="523220"/>
+                  <a:ext cx="734184" cy="400110"/>
                 </a:xfrm>
                 <a:prstGeom prst="rect">
                   <a:avLst/>
@@ -15462,20 +15462,20 @@
                 <a:p>
                   <a:pPr algn="ctr"/>
                   <a:r>
-                    <a:rPr lang="en-US" sz="2800" b="1" dirty="0"/>
+                    <a:rPr lang="en-US" sz="2000" b="1" dirty="0"/>
                     <a:t>Pipe </a:t>
                   </a:r>
                   <a14:m>
                     <m:oMath xmlns:m="http://schemas.openxmlformats.org/officeDocument/2006/math">
                       <m:r>
-                        <a:rPr lang="de-DE" sz="2800" b="1" i="1" dirty="0" smtClean="0">
+                        <a:rPr lang="de-DE" sz="2000" b="1" i="1" dirty="0" smtClean="0">
                           <a:latin typeface="Cambria Math" panose="02040503050406030204" pitchFamily="18" charset="0"/>
                         </a:rPr>
                         <m:t>𝟐</m:t>
                       </m:r>
                     </m:oMath>
                   </a14:m>
-                  <a:endParaRPr lang="en-DE" sz="2800" b="1" dirty="0"/>
+                  <a:endParaRPr lang="en-DE" sz="2000" b="1" dirty="0"/>
                 </a:p>
               </p:txBody>
             </p:sp>
@@ -15498,7 +15498,7 @@
               <p:spPr>
                 <a:xfrm>
                   <a:off x="5372824" y="4250468"/>
-                  <a:ext cx="734184" cy="523220"/>
+                  <a:ext cx="734184" cy="400110"/>
                 </a:xfrm>
                 <a:prstGeom prst="rect">
                   <a:avLst/>
@@ -15506,7 +15506,7 @@
                 <a:blipFill>
                   <a:blip r:embed="rId13"/>
                   <a:stretch>
-                    <a:fillRect l="-7767" t="-12791" b="-31395"/>
+                    <a:fillRect t="-7692" b="-29231"/>
                   </a:stretch>
                 </a:blipFill>
               </p:spPr>
@@ -15541,9 +15541,9 @@
         <p:grpSpPr>
           <a:xfrm>
             <a:off x="3087708" y="4657482"/>
-            <a:ext cx="1255894" cy="523220"/>
+            <a:ext cx="1255894" cy="400110"/>
             <a:chOff x="5372824" y="4250468"/>
-            <a:chExt cx="734184" cy="523220"/>
+            <a:chExt cx="734184" cy="400110"/>
           </a:xfrm>
         </p:grpSpPr>
         <p:sp>
@@ -15596,7 +15596,7 @@
             <a:lstStyle/>
             <a:p>
               <a:pPr algn="ctr"/>
-              <a:endParaRPr lang="en-US" sz="2800" b="1"/>
+              <a:endParaRPr lang="en-US" sz="2000" b="1"/>
             </a:p>
           </p:txBody>
         </p:sp>
@@ -15617,7 +15617,7 @@
               <p:spPr>
                 <a:xfrm>
                   <a:off x="5372824" y="4250468"/>
-                  <a:ext cx="734184" cy="523220"/>
+                  <a:ext cx="734184" cy="400110"/>
                 </a:xfrm>
                 <a:prstGeom prst="rect">
                   <a:avLst/>
@@ -15632,20 +15632,20 @@
                 <a:p>
                   <a:pPr algn="ctr"/>
                   <a:r>
-                    <a:rPr lang="en-US" sz="2800" b="1" dirty="0"/>
+                    <a:rPr lang="en-US" sz="2000" b="1" dirty="0"/>
                     <a:t>Pipe </a:t>
                   </a:r>
                   <a14:m>
                     <m:oMath xmlns:m="http://schemas.openxmlformats.org/officeDocument/2006/math">
                       <m:r>
-                        <a:rPr lang="de-DE" sz="2800" b="1" i="1" dirty="0" smtClean="0">
+                        <a:rPr lang="de-DE" sz="2000" b="1" i="1" dirty="0" smtClean="0">
                           <a:latin typeface="Cambria Math" panose="02040503050406030204" pitchFamily="18" charset="0"/>
                         </a:rPr>
                         <m:t>𝟑</m:t>
                       </m:r>
                     </m:oMath>
                   </a14:m>
-                  <a:endParaRPr lang="en-DE" sz="2800" b="1" dirty="0"/>
+                  <a:endParaRPr lang="en-DE" sz="2000" b="1" dirty="0"/>
                 </a:p>
               </p:txBody>
             </p:sp>
@@ -15668,7 +15668,7 @@
               <p:spPr>
                 <a:xfrm>
                   <a:off x="5372824" y="4250468"/>
-                  <a:ext cx="734184" cy="523220"/>
+                  <a:ext cx="734184" cy="400110"/>
                 </a:xfrm>
                 <a:prstGeom prst="rect">
                   <a:avLst/>
@@ -15676,7 +15676,7 @@
                 <a:blipFill>
                   <a:blip r:embed="rId14"/>
                   <a:stretch>
-                    <a:fillRect l="-7767" t="-11628" b="-31395"/>
+                    <a:fillRect t="-6061" b="-27273"/>
                   </a:stretch>
                 </a:blipFill>
               </p:spPr>
@@ -15712,8 +15712,8 @@
             </p:nvSpPr>
             <p:spPr>
               <a:xfrm>
-                <a:off x="7182160" y="3146004"/>
-                <a:ext cx="919162" cy="523220"/>
+                <a:off x="7108189" y="3488945"/>
+                <a:ext cx="709553" cy="400110"/>
               </a:xfrm>
               <a:prstGeom prst="rect">
                 <a:avLst/>
@@ -15736,14 +15736,14 @@
                       <m:sSub>
                         <m:sSubPr>
                           <m:ctrlPr>
-                            <a:rPr lang="en-US" sz="2800" i="1" smtClean="0">
+                            <a:rPr lang="en-US" sz="2000" i="1" smtClean="0">
                               <a:latin typeface="Cambria Math" panose="02040503050406030204" pitchFamily="18" charset="0"/>
                             </a:rPr>
                           </m:ctrlPr>
                         </m:sSubPr>
                         <m:e>
                           <m:r>
-                            <a:rPr lang="en-US" sz="2800" b="0" i="1" smtClean="0">
+                            <a:rPr lang="en-US" sz="2000" b="0" i="1" smtClean="0">
                               <a:latin typeface="Cambria Math" panose="02040503050406030204" pitchFamily="18" charset="0"/>
                             </a:rPr>
                             <m:t>𝑃</m:t>
@@ -15751,13 +15751,13 @@
                         </m:e>
                         <m:sub>
                           <m:r>
-                            <a:rPr lang="de-DE" sz="2800" b="0" i="1" smtClean="0">
+                            <a:rPr lang="de-DE" sz="2000" b="0" i="1" smtClean="0">
                               <a:latin typeface="Cambria Math" panose="02040503050406030204" pitchFamily="18" charset="0"/>
                             </a:rPr>
                             <m:t>𝑏</m:t>
                           </m:r>
                           <m:r>
-                            <a:rPr lang="de-DE" sz="2800" b="0" i="1" smtClean="0">
+                            <a:rPr lang="de-DE" sz="2000" b="0" i="1" smtClean="0">
                               <a:latin typeface="Cambria Math" panose="02040503050406030204" pitchFamily="18" charset="0"/>
                             </a:rPr>
                             <m:t>33</m:t>
@@ -15767,7 +15767,7 @@
                     </m:oMath>
                   </m:oMathPara>
                 </a14:m>
-                <a:endParaRPr lang="en-US" sz="2800" dirty="0"/>
+                <a:endParaRPr lang="en-US" sz="2000" dirty="0"/>
               </a:p>
             </p:txBody>
           </p:sp>
@@ -15789,8 +15789,8 @@
             </p:nvSpPr>
             <p:spPr>
               <a:xfrm>
-                <a:off x="7182160" y="3146004"/>
-                <a:ext cx="919162" cy="523220"/>
+                <a:off x="7108189" y="3488945"/>
+                <a:ext cx="709553" cy="400110"/>
               </a:xfrm>
               <a:prstGeom prst="rect">
                 <a:avLst/>
@@ -15833,8 +15833,8 @@
             </p:nvSpPr>
             <p:spPr>
               <a:xfrm>
-                <a:off x="5267503" y="4348918"/>
-                <a:ext cx="919162" cy="523220"/>
+                <a:off x="5372212" y="4610629"/>
+                <a:ext cx="709553" cy="400110"/>
               </a:xfrm>
               <a:prstGeom prst="rect">
                 <a:avLst/>
@@ -15857,14 +15857,14 @@
                       <m:sSub>
                         <m:sSubPr>
                           <m:ctrlPr>
-                            <a:rPr lang="en-US" sz="2800" i="1" smtClean="0">
+                            <a:rPr lang="en-US" sz="2000" i="1" smtClean="0">
                               <a:latin typeface="Cambria Math" panose="02040503050406030204" pitchFamily="18" charset="0"/>
                             </a:rPr>
                           </m:ctrlPr>
                         </m:sSubPr>
                         <m:e>
                           <m:r>
-                            <a:rPr lang="en-US" sz="2800" b="0" i="1" smtClean="0">
+                            <a:rPr lang="en-US" sz="2000" b="0" i="1" smtClean="0">
                               <a:latin typeface="Cambria Math" panose="02040503050406030204" pitchFamily="18" charset="0"/>
                             </a:rPr>
                             <m:t>𝑃</m:t>
@@ -15872,13 +15872,13 @@
                         </m:e>
                         <m:sub>
                           <m:r>
-                            <a:rPr lang="de-DE" sz="2800" b="0" i="1" smtClean="0">
+                            <a:rPr lang="de-DE" sz="2000" b="0" i="1" smtClean="0">
                               <a:latin typeface="Cambria Math" panose="02040503050406030204" pitchFamily="18" charset="0"/>
                             </a:rPr>
                             <m:t>𝑏</m:t>
                           </m:r>
                           <m:r>
-                            <a:rPr lang="de-DE" sz="2800" b="0" i="1" smtClean="0">
+                            <a:rPr lang="de-DE" sz="2000" b="0" i="1" smtClean="0">
                               <a:latin typeface="Cambria Math" panose="02040503050406030204" pitchFamily="18" charset="0"/>
                             </a:rPr>
                             <m:t>32</m:t>
@@ -15888,7 +15888,7 @@
                     </m:oMath>
                   </m:oMathPara>
                 </a14:m>
-                <a:endParaRPr lang="en-US" sz="2800" dirty="0"/>
+                <a:endParaRPr lang="en-US" sz="2000" dirty="0"/>
               </a:p>
             </p:txBody>
           </p:sp>
@@ -15910,8 +15910,8 @@
             </p:nvSpPr>
             <p:spPr>
               <a:xfrm>
-                <a:off x="5267503" y="4348918"/>
-                <a:ext cx="919162" cy="523220"/>
+                <a:off x="5372212" y="4610629"/>
+                <a:ext cx="709553" cy="400110"/>
               </a:xfrm>
               <a:prstGeom prst="rect">
                 <a:avLst/>
@@ -16078,7 +16078,7 @@
             <p:spPr>
               <a:xfrm>
                 <a:off x="1334688" y="1387801"/>
-                <a:ext cx="931986" cy="523220"/>
+                <a:ext cx="719171" cy="400110"/>
               </a:xfrm>
               <a:prstGeom prst="rect">
                 <a:avLst/>
@@ -16101,14 +16101,14 @@
                       <m:sSub>
                         <m:sSubPr>
                           <m:ctrlPr>
-                            <a:rPr lang="en-US" sz="2800" i="1" smtClean="0">
+                            <a:rPr lang="en-US" sz="2000" i="1" smtClean="0">
                               <a:latin typeface="Cambria Math" panose="02040503050406030204" pitchFamily="18" charset="0"/>
                             </a:rPr>
                           </m:ctrlPr>
                         </m:sSubPr>
                         <m:e>
                           <m:r>
-                            <a:rPr lang="en-US" sz="2800" b="0" i="1" smtClean="0">
+                            <a:rPr lang="en-US" sz="2000" b="0" i="1" smtClean="0">
                               <a:latin typeface="Cambria Math" panose="02040503050406030204" pitchFamily="18" charset="0"/>
                             </a:rPr>
                             <m:t>𝑃</m:t>
@@ -16116,13 +16116,13 @@
                         </m:e>
                         <m:sub>
                           <m:r>
-                            <a:rPr lang="en-US" sz="2800" b="0" i="1" smtClean="0">
+                            <a:rPr lang="en-US" sz="2000" b="0" i="1" smtClean="0">
                               <a:latin typeface="Cambria Math" panose="02040503050406030204" pitchFamily="18" charset="0"/>
                             </a:rPr>
                             <m:t>𝑢</m:t>
                           </m:r>
                           <m:r>
-                            <a:rPr lang="en-US" sz="2800" b="0" i="1" smtClean="0">
+                            <a:rPr lang="en-US" sz="2000" b="0" i="1" smtClean="0">
                               <a:latin typeface="Cambria Math" panose="02040503050406030204" pitchFamily="18" charset="0"/>
                             </a:rPr>
                             <m:t>01</m:t>
@@ -16132,7 +16132,7 @@
                     </m:oMath>
                   </m:oMathPara>
                 </a14:m>
-                <a:endParaRPr lang="en-US" sz="2800" dirty="0"/>
+                <a:endParaRPr lang="en-US" sz="2000" dirty="0"/>
               </a:p>
             </p:txBody>
           </p:sp>
@@ -16155,7 +16155,7 @@
             <p:spPr>
               <a:xfrm>
                 <a:off x="1334688" y="1387801"/>
-                <a:ext cx="931986" cy="523220"/>
+                <a:ext cx="719171" cy="400110"/>
               </a:xfrm>
               <a:prstGeom prst="rect">
                 <a:avLst/>
@@ -16198,8 +16198,8 @@
             </p:nvSpPr>
             <p:spPr>
               <a:xfrm>
-                <a:off x="7173916" y="1958541"/>
-                <a:ext cx="919162" cy="523220"/>
+                <a:off x="7392976" y="2148364"/>
+                <a:ext cx="709553" cy="400110"/>
               </a:xfrm>
               <a:prstGeom prst="rect">
                 <a:avLst/>
@@ -16222,14 +16222,14 @@
                       <m:sSub>
                         <m:sSubPr>
                           <m:ctrlPr>
-                            <a:rPr lang="en-US" sz="2800" i="1" smtClean="0">
+                            <a:rPr lang="en-US" sz="2000" i="1" smtClean="0">
                               <a:latin typeface="Cambria Math" panose="02040503050406030204" pitchFamily="18" charset="0"/>
                             </a:rPr>
                           </m:ctrlPr>
                         </m:sSubPr>
                         <m:e>
                           <m:r>
-                            <a:rPr lang="en-US" sz="2800" b="0" i="1" smtClean="0">
+                            <a:rPr lang="en-US" sz="2000" b="0" i="1" smtClean="0">
                               <a:latin typeface="Cambria Math" panose="02040503050406030204" pitchFamily="18" charset="0"/>
                             </a:rPr>
                             <m:t>𝑃</m:t>
@@ -16237,13 +16237,13 @@
                         </m:e>
                         <m:sub>
                           <m:r>
-                            <a:rPr lang="en-US" sz="2800" b="0" i="1" smtClean="0">
+                            <a:rPr lang="en-US" sz="2000" b="0" i="1" smtClean="0">
                               <a:latin typeface="Cambria Math" panose="02040503050406030204" pitchFamily="18" charset="0"/>
                             </a:rPr>
                             <m:t>𝑏</m:t>
                           </m:r>
                           <m:r>
-                            <a:rPr lang="de-DE" sz="2800" b="0" i="1" smtClean="0">
+                            <a:rPr lang="de-DE" sz="2000" b="0" i="1" smtClean="0">
                               <a:latin typeface="Cambria Math" panose="02040503050406030204" pitchFamily="18" charset="0"/>
                             </a:rPr>
                             <m:t>23</m:t>
@@ -16253,7 +16253,7 @@
                     </m:oMath>
                   </m:oMathPara>
                 </a14:m>
-                <a:endParaRPr lang="en-US" sz="2800" dirty="0"/>
+                <a:endParaRPr lang="en-US" sz="2000" dirty="0"/>
               </a:p>
             </p:txBody>
           </p:sp>
@@ -16275,8 +16275,8 @@
             </p:nvSpPr>
             <p:spPr>
               <a:xfrm>
-                <a:off x="7173916" y="1958541"/>
-                <a:ext cx="919162" cy="523220"/>
+                <a:off x="7392976" y="2148364"/>
+                <a:ext cx="709553" cy="400110"/>
               </a:xfrm>
               <a:prstGeom prst="rect">
                 <a:avLst/>
@@ -16319,8 +16319,8 @@
             </p:nvSpPr>
             <p:spPr>
               <a:xfrm>
-                <a:off x="5414757" y="2099000"/>
-                <a:ext cx="786241" cy="523220"/>
+                <a:off x="5232369" y="2068673"/>
+                <a:ext cx="610167" cy="400110"/>
               </a:xfrm>
               <a:prstGeom prst="rect">
                 <a:avLst/>
@@ -16343,28 +16343,28 @@
                       <m:sSub>
                         <m:sSubPr>
                           <m:ctrlPr>
-                            <a:rPr lang="en-US" sz="2800" i="1" smtClean="0">
+                            <a:rPr lang="en-US" sz="2000" i="1" smtClean="0">
                               <a:latin typeface="Cambria Math" panose="02040503050406030204" pitchFamily="18" charset="0"/>
                             </a:rPr>
                           </m:ctrlPr>
                         </m:sSubPr>
                         <m:e>
                           <m:r>
-                            <a:rPr lang="de-DE" sz="2800" b="0" i="1" smtClean="0">
-                              <a:latin typeface="Cambria Math" panose="02040503050406030204" pitchFamily="18" charset="0"/>
-                            </a:rPr>
-                            <m:t>𝐿</m:t>
+                            <a:rPr lang="tr-TR" sz="2000" b="0" i="1" smtClean="0">
+                              <a:latin typeface="Cambria Math" panose="02040503050406030204" pitchFamily="18" charset="0"/>
+                            </a:rPr>
+                            <m:t>𝑃</m:t>
                           </m:r>
                         </m:e>
                         <m:sub>
                           <m:r>
-                            <a:rPr lang="de-DE" sz="2800" b="0" i="1" smtClean="0">
+                            <a:rPr lang="de-DE" sz="2000" b="0" i="1" smtClean="0">
                               <a:latin typeface="Cambria Math" panose="02040503050406030204" pitchFamily="18" charset="0"/>
                             </a:rPr>
                             <m:t>𝑢</m:t>
                           </m:r>
                           <m:r>
-                            <a:rPr lang="de-DE" sz="2800" b="0" i="1" smtClean="0">
+                            <a:rPr lang="de-DE" sz="2000" b="0" i="1" smtClean="0">
                               <a:latin typeface="Cambria Math" panose="02040503050406030204" pitchFamily="18" charset="0"/>
                             </a:rPr>
                             <m:t>1</m:t>
@@ -16374,7 +16374,7 @@
                     </m:oMath>
                   </m:oMathPara>
                 </a14:m>
-                <a:endParaRPr lang="en-US" sz="2800" dirty="0"/>
+                <a:endParaRPr lang="en-US" sz="2000" dirty="0"/>
               </a:p>
             </p:txBody>
           </p:sp>
@@ -16396,8 +16396,8 @@
             </p:nvSpPr>
             <p:spPr>
               <a:xfrm>
-                <a:off x="5414757" y="2099000"/>
-                <a:ext cx="786241" cy="523220"/>
+                <a:off x="5232369" y="2068673"/>
+                <a:ext cx="610167" cy="400110"/>
               </a:xfrm>
               <a:prstGeom prst="rect">
                 <a:avLst/>
@@ -16523,7 +16523,7 @@
             <p:spPr>
               <a:xfrm>
                 <a:off x="1103160" y="3724990"/>
-                <a:ext cx="919162" cy="523220"/>
+                <a:ext cx="709553" cy="400110"/>
               </a:xfrm>
               <a:prstGeom prst="rect">
                 <a:avLst/>
@@ -16546,14 +16546,14 @@
                       <m:sSub>
                         <m:sSubPr>
                           <m:ctrlPr>
-                            <a:rPr lang="en-US" sz="2800" i="1" smtClean="0">
+                            <a:rPr lang="en-US" sz="2000" i="1" smtClean="0">
                               <a:latin typeface="Cambria Math" panose="02040503050406030204" pitchFamily="18" charset="0"/>
                             </a:rPr>
                           </m:ctrlPr>
                         </m:sSubPr>
                         <m:e>
                           <m:r>
-                            <a:rPr lang="en-US" sz="2800" b="0" i="1" smtClean="0">
+                            <a:rPr lang="en-US" sz="2000" b="0" i="1" smtClean="0">
                               <a:latin typeface="Cambria Math" panose="02040503050406030204" pitchFamily="18" charset="0"/>
                             </a:rPr>
                             <m:t>𝑃</m:t>
@@ -16561,13 +16561,13 @@
                         </m:e>
                         <m:sub>
                           <m:r>
-                            <a:rPr lang="en-US" sz="2800" b="0" i="1" smtClean="0">
+                            <a:rPr lang="en-US" sz="2000" b="0" i="1" smtClean="0">
                               <a:latin typeface="Cambria Math" panose="02040503050406030204" pitchFamily="18" charset="0"/>
                             </a:rPr>
                             <m:t>𝑏</m:t>
                           </m:r>
                           <m:r>
-                            <a:rPr lang="en-US" sz="2800" b="0" i="1" smtClean="0">
+                            <a:rPr lang="en-US" sz="2000" b="0" i="1" smtClean="0">
                               <a:latin typeface="Cambria Math" panose="02040503050406030204" pitchFamily="18" charset="0"/>
                             </a:rPr>
                             <m:t>01</m:t>
@@ -16577,7 +16577,7 @@
                     </m:oMath>
                   </m:oMathPara>
                 </a14:m>
-                <a:endParaRPr lang="en-US" sz="2800" dirty="0"/>
+                <a:endParaRPr lang="en-US" sz="2000" dirty="0"/>
               </a:p>
             </p:txBody>
           </p:sp>
@@ -16600,7 +16600,7 @@
             <p:spPr>
               <a:xfrm>
                 <a:off x="1103160" y="3724990"/>
-                <a:ext cx="919162" cy="523220"/>
+                <a:ext cx="709553" cy="400110"/>
               </a:xfrm>
               <a:prstGeom prst="rect">
                 <a:avLst/>
@@ -16645,7 +16645,7 @@
         <p:spPr>
           <a:xfrm flipH="1" flipV="1">
             <a:off x="2870517" y="3211737"/>
-            <a:ext cx="483051" cy="252701"/>
+            <a:ext cx="483051" cy="191146"/>
           </a:xfrm>
           <a:prstGeom prst="straightConnector1">
             <a:avLst/>
@@ -16685,8 +16685,8 @@
             </p:nvSpPr>
             <p:spPr>
               <a:xfrm>
-                <a:off x="5414757" y="3191200"/>
-                <a:ext cx="773417" cy="523220"/>
+                <a:off x="5161858" y="3211429"/>
+                <a:ext cx="600549" cy="400110"/>
               </a:xfrm>
               <a:prstGeom prst="rect">
                 <a:avLst/>
@@ -16709,28 +16709,28 @@
                       <m:sSub>
                         <m:sSubPr>
                           <m:ctrlPr>
-                            <a:rPr lang="en-US" sz="2800" i="1" smtClean="0">
+                            <a:rPr lang="en-US" sz="2000" i="1" smtClean="0">
                               <a:latin typeface="Cambria Math" panose="02040503050406030204" pitchFamily="18" charset="0"/>
                             </a:rPr>
                           </m:ctrlPr>
                         </m:sSubPr>
                         <m:e>
                           <m:r>
-                            <a:rPr lang="de-DE" sz="2800" b="0" i="1" smtClean="0">
-                              <a:latin typeface="Cambria Math" panose="02040503050406030204" pitchFamily="18" charset="0"/>
-                            </a:rPr>
-                            <m:t>𝐿</m:t>
+                            <a:rPr lang="tr-TR" sz="2000" b="0" i="1" smtClean="0">
+                              <a:latin typeface="Cambria Math" panose="02040503050406030204" pitchFamily="18" charset="0"/>
+                            </a:rPr>
+                            <m:t>𝑃</m:t>
                           </m:r>
                         </m:e>
                         <m:sub>
                           <m:r>
-                            <a:rPr lang="de-DE" sz="2800" b="0" i="1" smtClean="0">
+                            <a:rPr lang="de-DE" sz="2000" b="0" i="1" smtClean="0">
                               <a:latin typeface="Cambria Math" panose="02040503050406030204" pitchFamily="18" charset="0"/>
                             </a:rPr>
                             <m:t>𝑏</m:t>
                           </m:r>
                           <m:r>
-                            <a:rPr lang="de-DE" sz="2800" b="0" i="1" smtClean="0">
+                            <a:rPr lang="de-DE" sz="2000" b="0" i="1" smtClean="0">
                               <a:latin typeface="Cambria Math" panose="02040503050406030204" pitchFamily="18" charset="0"/>
                             </a:rPr>
                             <m:t>1</m:t>
@@ -16740,7 +16740,7 @@
                     </m:oMath>
                   </m:oMathPara>
                 </a14:m>
-                <a:endParaRPr lang="en-US" sz="2800" dirty="0"/>
+                <a:endParaRPr lang="en-US" sz="2000" dirty="0"/>
               </a:p>
             </p:txBody>
           </p:sp>
@@ -16762,8 +16762,8 @@
             </p:nvSpPr>
             <p:spPr>
               <a:xfrm>
-                <a:off x="5414757" y="3191200"/>
-                <a:ext cx="773417" cy="523220"/>
+                <a:off x="5161858" y="3211429"/>
+                <a:ext cx="600549" cy="400110"/>
               </a:xfrm>
               <a:prstGeom prst="rect">
                 <a:avLst/>
@@ -16771,7 +16771,7 @@
               <a:blipFill>
                 <a:blip r:embed="rId21"/>
                 <a:stretch>
-                  <a:fillRect/>
+                  <a:fillRect b="-1538"/>
                 </a:stretch>
               </a:blipFill>
             </p:spPr>
@@ -16806,8 +16806,8 @@
         </p:nvCxnSpPr>
         <p:spPr>
           <a:xfrm flipH="1" flipV="1">
-            <a:off x="9575110" y="3099875"/>
-            <a:ext cx="3464" cy="419531"/>
+            <a:off x="9393130" y="3271081"/>
+            <a:ext cx="404519" cy="381675"/>
           </a:xfrm>
           <a:prstGeom prst="straightConnector1">
             <a:avLst/>
@@ -16847,8 +16847,8 @@
         </p:nvCxnSpPr>
         <p:spPr>
           <a:xfrm>
-            <a:off x="9549796" y="2846070"/>
-            <a:ext cx="577828" cy="0"/>
+            <a:off x="9900704" y="3046095"/>
+            <a:ext cx="467563" cy="0"/>
           </a:xfrm>
           <a:prstGeom prst="line">
             <a:avLst/>
@@ -16884,9 +16884,9 @@
           <p:nvPr/>
         </p:nvCxnSpPr>
         <p:spPr>
-          <a:xfrm flipV="1">
-            <a:off x="9534578" y="3029958"/>
-            <a:ext cx="614614" cy="5454"/>
+          <a:xfrm>
+            <a:off x="9341921" y="3216654"/>
+            <a:ext cx="1026346" cy="13329"/>
           </a:xfrm>
           <a:prstGeom prst="line">
             <a:avLst/>
@@ -16923,7 +16923,7 @@
         </p:nvCxnSpPr>
         <p:spPr>
           <a:xfrm flipV="1">
-            <a:off x="8062316" y="3227490"/>
+            <a:off x="7688701" y="3476587"/>
             <a:ext cx="483051" cy="252701"/>
           </a:xfrm>
           <a:prstGeom prst="straightConnector1">
@@ -16964,7 +16964,7 @@
         </p:nvCxnSpPr>
         <p:spPr>
           <a:xfrm>
-            <a:off x="8047421" y="2327350"/>
+            <a:off x="8273934" y="2583880"/>
             <a:ext cx="483051" cy="252701"/>
           </a:xfrm>
           <a:prstGeom prst="straightConnector1">
@@ -17006,7 +17006,7 @@
             <p:spPr>
               <a:xfrm>
                 <a:off x="104710" y="2099000"/>
-                <a:ext cx="931986" cy="523220"/>
+                <a:ext cx="719171" cy="400110"/>
               </a:xfrm>
               <a:prstGeom prst="rect">
                 <a:avLst/>
@@ -17029,14 +17029,14 @@
                       <m:sSub>
                         <m:sSubPr>
                           <m:ctrlPr>
-                            <a:rPr lang="en-US" sz="2800" i="1" smtClean="0">
+                            <a:rPr lang="en-US" sz="2000" i="1" smtClean="0">
                               <a:latin typeface="Cambria Math" panose="02040503050406030204" pitchFamily="18" charset="0"/>
                             </a:rPr>
                           </m:ctrlPr>
                         </m:sSubPr>
                         <m:e>
                           <m:r>
-                            <a:rPr lang="en-US" sz="2800" b="0" i="1" smtClean="0">
+                            <a:rPr lang="en-US" sz="2000" b="0" i="1" smtClean="0">
                               <a:latin typeface="Cambria Math" panose="02040503050406030204" pitchFamily="18" charset="0"/>
                             </a:rPr>
                             <m:t>𝑃</m:t>
@@ -17044,13 +17044,13 @@
                         </m:e>
                         <m:sub>
                           <m:r>
-                            <a:rPr lang="en-US" sz="2800" b="0" i="1" smtClean="0">
+                            <a:rPr lang="en-US" sz="2000" b="0" i="1" smtClean="0">
                               <a:latin typeface="Cambria Math" panose="02040503050406030204" pitchFamily="18" charset="0"/>
                             </a:rPr>
                             <m:t>𝑢</m:t>
                           </m:r>
                           <m:r>
-                            <a:rPr lang="en-US" sz="2800" b="0" i="1" smtClean="0">
+                            <a:rPr lang="en-US" sz="2000" b="0" i="1" smtClean="0">
                               <a:latin typeface="Cambria Math" panose="02040503050406030204" pitchFamily="18" charset="0"/>
                             </a:rPr>
                             <m:t>00</m:t>
@@ -17060,7 +17060,7 @@
                     </m:oMath>
                   </m:oMathPara>
                 </a14:m>
-                <a:endParaRPr lang="en-US" sz="2800" dirty="0"/>
+                <a:endParaRPr lang="en-US" sz="2000" dirty="0"/>
               </a:p>
             </p:txBody>
           </p:sp>
@@ -17083,7 +17083,7 @@
             <p:spPr>
               <a:xfrm>
                 <a:off x="104710" y="2099000"/>
-                <a:ext cx="931986" cy="523220"/>
+                <a:ext cx="719171" cy="400110"/>
               </a:xfrm>
               <a:prstGeom prst="rect">
                 <a:avLst/>
@@ -17127,7 +17127,7 @@
             <p:spPr>
               <a:xfrm>
                 <a:off x="0" y="3092230"/>
-                <a:ext cx="919162" cy="523220"/>
+                <a:ext cx="709553" cy="400110"/>
               </a:xfrm>
               <a:prstGeom prst="rect">
                 <a:avLst/>
@@ -17150,14 +17150,14 @@
                       <m:sSub>
                         <m:sSubPr>
                           <m:ctrlPr>
-                            <a:rPr lang="en-US" sz="2800" i="1" smtClean="0">
+                            <a:rPr lang="en-US" sz="2000" i="1" smtClean="0">
                               <a:latin typeface="Cambria Math" panose="02040503050406030204" pitchFamily="18" charset="0"/>
                             </a:rPr>
                           </m:ctrlPr>
                         </m:sSubPr>
                         <m:e>
                           <m:r>
-                            <a:rPr lang="en-US" sz="2800" b="0" i="1" smtClean="0">
+                            <a:rPr lang="en-US" sz="2000" b="0" i="1" smtClean="0">
                               <a:latin typeface="Cambria Math" panose="02040503050406030204" pitchFamily="18" charset="0"/>
                             </a:rPr>
                             <m:t>𝑃</m:t>
@@ -17165,13 +17165,13 @@
                         </m:e>
                         <m:sub>
                           <m:r>
-                            <a:rPr lang="en-US" sz="2800" b="0" i="1" smtClean="0">
+                            <a:rPr lang="en-US" sz="2000" b="0" i="1" smtClean="0">
                               <a:latin typeface="Cambria Math" panose="02040503050406030204" pitchFamily="18" charset="0"/>
                             </a:rPr>
                             <m:t>𝑏</m:t>
                           </m:r>
                           <m:r>
-                            <a:rPr lang="en-US" sz="2800" b="0" i="1" smtClean="0">
+                            <a:rPr lang="en-US" sz="2000" b="0" i="1" smtClean="0">
                               <a:latin typeface="Cambria Math" panose="02040503050406030204" pitchFamily="18" charset="0"/>
                             </a:rPr>
                             <m:t>00</m:t>
@@ -17181,7 +17181,7 @@
                     </m:oMath>
                   </m:oMathPara>
                 </a14:m>
-                <a:endParaRPr lang="en-US" sz="2800" dirty="0"/>
+                <a:endParaRPr lang="en-US" sz="2000" dirty="0"/>
               </a:p>
             </p:txBody>
           </p:sp>
@@ -17204,7 +17204,7 @@
             <p:spPr>
               <a:xfrm>
                 <a:off x="0" y="3092230"/>
-                <a:ext cx="919162" cy="523220"/>
+                <a:ext cx="709553" cy="400110"/>
               </a:xfrm>
               <a:prstGeom prst="rect">
                 <a:avLst/>
@@ -17408,7 +17408,7 @@
         </p:nvCxnSpPr>
         <p:spPr>
           <a:xfrm>
-            <a:off x="8744362" y="3227489"/>
+            <a:off x="8412953" y="3429000"/>
             <a:ext cx="215567" cy="213790"/>
           </a:xfrm>
           <a:prstGeom prst="line">
@@ -17490,8 +17490,8 @@
         </p:nvCxnSpPr>
         <p:spPr>
           <a:xfrm flipH="1">
-            <a:off x="8727067" y="2461143"/>
-            <a:ext cx="193860" cy="179567"/>
+            <a:off x="9123174" y="2713832"/>
+            <a:ext cx="218747" cy="177031"/>
           </a:xfrm>
           <a:prstGeom prst="line">
             <a:avLst/>
@@ -17613,7 +17613,7 @@
         </p:nvCxnSpPr>
         <p:spPr>
           <a:xfrm>
-            <a:off x="8905654" y="1559263"/>
+            <a:off x="9368778" y="1866348"/>
             <a:ext cx="0" cy="777286"/>
           </a:xfrm>
           <a:prstGeom prst="straightConnector1">
@@ -17654,7 +17654,7 @@
         </p:nvCxnSpPr>
         <p:spPr>
           <a:xfrm flipH="1" flipV="1">
-            <a:off x="8994685" y="3519406"/>
+            <a:off x="8690396" y="3692091"/>
             <a:ext cx="374093" cy="376130"/>
           </a:xfrm>
           <a:prstGeom prst="straightConnector1">
@@ -17695,8 +17695,8 @@
             </p:nvSpPr>
             <p:spPr>
               <a:xfrm>
-                <a:off x="8627342" y="914867"/>
-                <a:ext cx="1084271" cy="523220"/>
+                <a:off x="8754439" y="1270443"/>
+                <a:ext cx="828175" cy="400110"/>
               </a:xfrm>
               <a:prstGeom prst="rect">
                 <a:avLst/>
@@ -17719,14 +17719,14 @@
                       <m:sSub>
                         <m:sSubPr>
                           <m:ctrlPr>
-                            <a:rPr lang="en-US" sz="2800" i="1" smtClean="0">
+                            <a:rPr lang="en-US" sz="2000" i="1" smtClean="0">
                               <a:latin typeface="Cambria Math" panose="02040503050406030204" pitchFamily="18" charset="0"/>
                             </a:rPr>
                           </m:ctrlPr>
                         </m:sSubPr>
                         <m:e>
                           <m:r>
-                            <a:rPr lang="en-US" sz="2800" b="0" i="1" smtClean="0">
+                            <a:rPr lang="en-US" sz="2000" b="0" i="1" smtClean="0">
                               <a:latin typeface="Cambria Math" panose="02040503050406030204" pitchFamily="18" charset="0"/>
                             </a:rPr>
                             <m:t>𝑃</m:t>
@@ -17734,19 +17734,19 @@
                         </m:e>
                         <m:sub>
                           <m:r>
-                            <a:rPr lang="en-US" sz="2800" b="0" i="1" smtClean="0">
+                            <a:rPr lang="en-US" sz="2000" b="0" i="1" smtClean="0">
                               <a:latin typeface="Cambria Math" panose="02040503050406030204" pitchFamily="18" charset="0"/>
                             </a:rPr>
                             <m:t>𝑢</m:t>
                           </m:r>
                           <m:r>
-                            <a:rPr lang="de-DE" sz="2800" b="0" i="1" smtClean="0">
+                            <a:rPr lang="de-DE" sz="2000" b="0" i="1" smtClean="0">
                               <a:latin typeface="Cambria Math" panose="02040503050406030204" pitchFamily="18" charset="0"/>
                             </a:rPr>
                             <m:t>22</m:t>
                           </m:r>
                           <m:r>
-                            <a:rPr lang="en-US" sz="2800" b="0" i="1" smtClean="0">
+                            <a:rPr lang="en-US" sz="2000" b="0" i="1" smtClean="0">
                               <a:latin typeface="Cambria Math" panose="02040503050406030204" pitchFamily="18" charset="0"/>
                             </a:rPr>
                             <m:t>2</m:t>
@@ -17756,7 +17756,7 @@
                     </m:oMath>
                   </m:oMathPara>
                 </a14:m>
-                <a:endParaRPr lang="en-US" sz="2800" dirty="0"/>
+                <a:endParaRPr lang="en-US" sz="2000" dirty="0"/>
               </a:p>
             </p:txBody>
           </p:sp>
@@ -17778,8 +17778,8 @@
             </p:nvSpPr>
             <p:spPr>
               <a:xfrm>
-                <a:off x="8627342" y="914867"/>
-                <a:ext cx="1084271" cy="523220"/>
+                <a:off x="8754439" y="1270443"/>
+                <a:ext cx="828175" cy="400110"/>
               </a:xfrm>
               <a:prstGeom prst="rect">
                 <a:avLst/>
@@ -17823,7 +17823,7 @@
             <p:spPr>
               <a:xfrm>
                 <a:off x="9072529" y="3895536"/>
-                <a:ext cx="1084271" cy="523220"/>
+                <a:ext cx="828175" cy="400110"/>
               </a:xfrm>
               <a:prstGeom prst="rect">
                 <a:avLst/>
@@ -17846,14 +17846,14 @@
                       <m:sSub>
                         <m:sSubPr>
                           <m:ctrlPr>
-                            <a:rPr lang="en-US" sz="2800" i="1" smtClean="0">
+                            <a:rPr lang="en-US" sz="2000" i="1" smtClean="0">
                               <a:latin typeface="Cambria Math" panose="02040503050406030204" pitchFamily="18" charset="0"/>
                             </a:rPr>
                           </m:ctrlPr>
                         </m:sSubPr>
                         <m:e>
                           <m:r>
-                            <a:rPr lang="en-US" sz="2800" b="0" i="1" smtClean="0">
+                            <a:rPr lang="en-US" sz="2000" b="0" i="1" smtClean="0">
                               <a:latin typeface="Cambria Math" panose="02040503050406030204" pitchFamily="18" charset="0"/>
                             </a:rPr>
                             <m:t>𝑃</m:t>
@@ -17861,13 +17861,13 @@
                         </m:e>
                         <m:sub>
                           <m:r>
-                            <a:rPr lang="en-US" sz="2800" b="0" i="1" smtClean="0">
+                            <a:rPr lang="en-US" sz="2000" b="0" i="1" smtClean="0">
                               <a:latin typeface="Cambria Math" panose="02040503050406030204" pitchFamily="18" charset="0"/>
                             </a:rPr>
                             <m:t>𝑢</m:t>
                           </m:r>
                           <m:r>
-                            <a:rPr lang="en-US" sz="2800" b="0" i="1" smtClean="0">
+                            <a:rPr lang="en-US" sz="2000" b="0" i="1" smtClean="0">
                               <a:latin typeface="Cambria Math" panose="02040503050406030204" pitchFamily="18" charset="0"/>
                             </a:rPr>
                             <m:t>322</m:t>
@@ -17877,7 +17877,7 @@
                     </m:oMath>
                   </m:oMathPara>
                 </a14:m>
-                <a:endParaRPr lang="en-US" sz="2800" dirty="0"/>
+                <a:endParaRPr lang="en-US" sz="2000" dirty="0"/>
               </a:p>
             </p:txBody>
           </p:sp>
@@ -17900,7 +17900,7 @@
             <p:spPr>
               <a:xfrm>
                 <a:off x="9072529" y="3895536"/>
-                <a:ext cx="1084271" cy="523220"/>
+                <a:ext cx="828175" cy="400110"/>
               </a:xfrm>
               <a:prstGeom prst="rect">
                 <a:avLst/>
@@ -17944,7 +17944,7 @@
             <p:spPr>
               <a:xfrm>
                 <a:off x="2191369" y="904011"/>
-                <a:ext cx="1084271" cy="523220"/>
+                <a:ext cx="828175" cy="400110"/>
               </a:xfrm>
               <a:prstGeom prst="rect">
                 <a:avLst/>
@@ -17967,14 +17967,14 @@
                       <m:sSub>
                         <m:sSubPr>
                           <m:ctrlPr>
-                            <a:rPr lang="en-US" sz="2800" i="1" smtClean="0">
+                            <a:rPr lang="en-US" sz="2000" i="1" smtClean="0">
                               <a:latin typeface="Cambria Math" panose="02040503050406030204" pitchFamily="18" charset="0"/>
                             </a:rPr>
                           </m:ctrlPr>
                         </m:sSubPr>
                         <m:e>
                           <m:r>
-                            <a:rPr lang="en-US" sz="2800" b="0" i="1" smtClean="0">
+                            <a:rPr lang="en-US" sz="2000" b="0" i="1" smtClean="0">
                               <a:latin typeface="Cambria Math" panose="02040503050406030204" pitchFamily="18" charset="0"/>
                             </a:rPr>
                             <m:t>𝑃</m:t>
@@ -17982,13 +17982,13 @@
                         </m:e>
                         <m:sub>
                           <m:r>
-                            <a:rPr lang="en-US" sz="2800" b="0" i="1" smtClean="0">
+                            <a:rPr lang="en-US" sz="2000" b="0" i="1" smtClean="0">
                               <a:latin typeface="Cambria Math" panose="02040503050406030204" pitchFamily="18" charset="0"/>
                             </a:rPr>
                             <m:t>𝑢</m:t>
                           </m:r>
                           <m:r>
-                            <a:rPr lang="en-US" sz="2800" b="0" i="1" smtClean="0">
+                            <a:rPr lang="en-US" sz="2000" b="0" i="1" smtClean="0">
                               <a:latin typeface="Cambria Math" panose="02040503050406030204" pitchFamily="18" charset="0"/>
                             </a:rPr>
                             <m:t>210</m:t>
@@ -17998,7 +17998,7 @@
                     </m:oMath>
                   </m:oMathPara>
                 </a14:m>
-                <a:endParaRPr lang="en-US" sz="2800" dirty="0"/>
+                <a:endParaRPr lang="en-US" sz="2000" dirty="0"/>
               </a:p>
             </p:txBody>
           </p:sp>
@@ -18021,7 +18021,7 @@
             <p:spPr>
               <a:xfrm>
                 <a:off x="2191369" y="904011"/>
-                <a:ext cx="1084271" cy="523220"/>
+                <a:ext cx="828175" cy="400110"/>
               </a:xfrm>
               <a:prstGeom prst="rect">
                 <a:avLst/>
@@ -18065,7 +18065,7 @@
             <p:spPr>
               <a:xfrm>
                 <a:off x="2019758" y="4221916"/>
-                <a:ext cx="1084271" cy="523220"/>
+                <a:ext cx="828175" cy="400110"/>
               </a:xfrm>
               <a:prstGeom prst="rect">
                 <a:avLst/>
@@ -18088,14 +18088,14 @@
                       <m:sSub>
                         <m:sSubPr>
                           <m:ctrlPr>
-                            <a:rPr lang="en-US" sz="2800" i="1" smtClean="0">
+                            <a:rPr lang="en-US" sz="2000" i="1" smtClean="0">
                               <a:latin typeface="Cambria Math" panose="02040503050406030204" pitchFamily="18" charset="0"/>
                             </a:rPr>
                           </m:ctrlPr>
                         </m:sSubPr>
                         <m:e>
                           <m:r>
-                            <a:rPr lang="en-US" sz="2800" b="0" i="1" smtClean="0">
+                            <a:rPr lang="en-US" sz="2000" b="0" i="1" smtClean="0">
                               <a:latin typeface="Cambria Math" panose="02040503050406030204" pitchFamily="18" charset="0"/>
                             </a:rPr>
                             <m:t>𝑃</m:t>
@@ -18103,13 +18103,13 @@
                         </m:e>
                         <m:sub>
                           <m:r>
-                            <a:rPr lang="en-US" sz="2800" b="0" i="1" smtClean="0">
+                            <a:rPr lang="en-US" sz="2000" b="0" i="1" smtClean="0">
                               <a:latin typeface="Cambria Math" panose="02040503050406030204" pitchFamily="18" charset="0"/>
                             </a:rPr>
                             <m:t>𝑢</m:t>
                           </m:r>
                           <m:r>
-                            <a:rPr lang="en-US" sz="2800" b="0" i="1" smtClean="0">
+                            <a:rPr lang="en-US" sz="2000" b="0" i="1" smtClean="0">
                               <a:latin typeface="Cambria Math" panose="02040503050406030204" pitchFamily="18" charset="0"/>
                             </a:rPr>
                             <m:t>310</m:t>
@@ -18119,7 +18119,7 @@
                     </m:oMath>
                   </m:oMathPara>
                 </a14:m>
-                <a:endParaRPr lang="en-US" sz="2800" dirty="0"/>
+                <a:endParaRPr lang="en-US" sz="2000" dirty="0"/>
               </a:p>
             </p:txBody>
           </p:sp>
@@ -18142,7 +18142,7 @@
             <p:spPr>
               <a:xfrm>
                 <a:off x="2019758" y="4221916"/>
-                <a:ext cx="1084271" cy="523220"/>
+                <a:ext cx="828175" cy="400110"/>
               </a:xfrm>
               <a:prstGeom prst="rect">
                 <a:avLst/>
@@ -18337,8 +18337,8 @@
             </p:nvSpPr>
             <p:spPr>
               <a:xfrm>
-                <a:off x="8208444" y="4500331"/>
-                <a:ext cx="786241" cy="523220"/>
+                <a:off x="8553229" y="4625082"/>
+                <a:ext cx="610167" cy="400110"/>
               </a:xfrm>
               <a:prstGeom prst="rect">
                 <a:avLst/>
@@ -18361,28 +18361,28 @@
                       <m:sSub>
                         <m:sSubPr>
                           <m:ctrlPr>
-                            <a:rPr lang="en-US" sz="2800" i="1" smtClean="0">
+                            <a:rPr lang="en-US" sz="2000" i="1" smtClean="0">
                               <a:latin typeface="Cambria Math" panose="02040503050406030204" pitchFamily="18" charset="0"/>
                             </a:rPr>
                           </m:ctrlPr>
                         </m:sSubPr>
                         <m:e>
                           <m:r>
-                            <a:rPr lang="de-DE" sz="2800" b="0" i="1" smtClean="0">
-                              <a:latin typeface="Cambria Math" panose="02040503050406030204" pitchFamily="18" charset="0"/>
-                            </a:rPr>
-                            <m:t>𝐿</m:t>
+                            <a:rPr lang="tr-TR" sz="2000" b="0" i="1" smtClean="0">
+                              <a:latin typeface="Cambria Math" panose="02040503050406030204" pitchFamily="18" charset="0"/>
+                            </a:rPr>
+                            <m:t>𝑃</m:t>
                           </m:r>
                         </m:e>
                         <m:sub>
                           <m:r>
-                            <a:rPr lang="de-DE" sz="2800" b="0" i="1" smtClean="0">
+                            <a:rPr lang="de-DE" sz="2000" b="0" i="1" smtClean="0">
                               <a:latin typeface="Cambria Math" panose="02040503050406030204" pitchFamily="18" charset="0"/>
                             </a:rPr>
                             <m:t>𝑢</m:t>
                           </m:r>
                           <m:r>
-                            <a:rPr lang="de-DE" sz="2800" b="0" i="1" smtClean="0">
+                            <a:rPr lang="de-DE" sz="2000" b="0" i="1" smtClean="0">
                               <a:latin typeface="Cambria Math" panose="02040503050406030204" pitchFamily="18" charset="0"/>
                             </a:rPr>
                             <m:t>1</m:t>
@@ -18392,7 +18392,7 @@
                     </m:oMath>
                   </m:oMathPara>
                 </a14:m>
-                <a:endParaRPr lang="en-US" sz="2800" dirty="0"/>
+                <a:endParaRPr lang="en-US" sz="2000" dirty="0"/>
               </a:p>
             </p:txBody>
           </p:sp>
@@ -18414,8 +18414,8 @@
             </p:nvSpPr>
             <p:spPr>
               <a:xfrm>
-                <a:off x="8208444" y="4500331"/>
-                <a:ext cx="786241" cy="523220"/>
+                <a:off x="8553229" y="4625082"/>
+                <a:ext cx="610167" cy="400110"/>
               </a:xfrm>
               <a:prstGeom prst="rect">
                 <a:avLst/>
@@ -18497,7 +18497,7 @@
             <p:spPr>
               <a:xfrm>
                 <a:off x="8240633" y="6133423"/>
-                <a:ext cx="773417" cy="523220"/>
+                <a:ext cx="600549" cy="400110"/>
               </a:xfrm>
               <a:prstGeom prst="rect">
                 <a:avLst/>
@@ -18520,28 +18520,28 @@
                       <m:sSub>
                         <m:sSubPr>
                           <m:ctrlPr>
-                            <a:rPr lang="en-US" sz="2800" i="1" smtClean="0">
+                            <a:rPr lang="en-US" sz="2000" i="1" smtClean="0">
                               <a:latin typeface="Cambria Math" panose="02040503050406030204" pitchFamily="18" charset="0"/>
                             </a:rPr>
                           </m:ctrlPr>
                         </m:sSubPr>
                         <m:e>
                           <m:r>
-                            <a:rPr lang="de-DE" sz="2800" b="0" i="1" smtClean="0">
-                              <a:latin typeface="Cambria Math" panose="02040503050406030204" pitchFamily="18" charset="0"/>
-                            </a:rPr>
-                            <m:t>𝐿</m:t>
+                            <a:rPr lang="tr-TR" sz="2000" b="0" i="1" smtClean="0">
+                              <a:latin typeface="Cambria Math" panose="02040503050406030204" pitchFamily="18" charset="0"/>
+                            </a:rPr>
+                            <m:t>𝑃</m:t>
                           </m:r>
                         </m:e>
                         <m:sub>
                           <m:r>
-                            <a:rPr lang="de-DE" sz="2800" b="0" i="1" smtClean="0">
+                            <a:rPr lang="de-DE" sz="2000" b="0" i="1" smtClean="0">
                               <a:latin typeface="Cambria Math" panose="02040503050406030204" pitchFamily="18" charset="0"/>
                             </a:rPr>
                             <m:t>𝑏</m:t>
                           </m:r>
                           <m:r>
-                            <a:rPr lang="de-DE" sz="2800" b="0" i="1" smtClean="0">
+                            <a:rPr lang="de-DE" sz="2000" b="0" i="1" smtClean="0">
                               <a:latin typeface="Cambria Math" panose="02040503050406030204" pitchFamily="18" charset="0"/>
                             </a:rPr>
                             <m:t>1</m:t>
@@ -18551,7 +18551,7 @@
                     </m:oMath>
                   </m:oMathPara>
                 </a14:m>
-                <a:endParaRPr lang="en-US" sz="2800" dirty="0"/>
+                <a:endParaRPr lang="en-US" sz="2000" dirty="0"/>
               </a:p>
             </p:txBody>
           </p:sp>
@@ -18574,7 +18574,7 @@
             <p:spPr>
               <a:xfrm>
                 <a:off x="8240633" y="6133423"/>
-                <a:ext cx="773417" cy="523220"/>
+                <a:ext cx="600549" cy="400110"/>
               </a:xfrm>
               <a:prstGeom prst="rect">
                 <a:avLst/>
@@ -18655,8 +18655,8 @@
             </p:nvSpPr>
             <p:spPr>
               <a:xfrm>
-                <a:off x="9509423" y="4850139"/>
-                <a:ext cx="938527" cy="523220"/>
+                <a:off x="9797649" y="5222974"/>
+                <a:ext cx="724301" cy="400110"/>
               </a:xfrm>
               <a:prstGeom prst="rect">
                 <a:avLst/>
@@ -18679,14 +18679,14 @@
                       <m:sSub>
                         <m:sSubPr>
                           <m:ctrlPr>
-                            <a:rPr lang="en-US" sz="2800" i="1" smtClean="0">
+                            <a:rPr lang="en-US" sz="2000" i="1" smtClean="0">
                               <a:latin typeface="Cambria Math" panose="02040503050406030204" pitchFamily="18" charset="0"/>
                             </a:rPr>
                           </m:ctrlPr>
                         </m:sSubPr>
                         <m:e>
                           <m:r>
-                            <a:rPr lang="de-DE" sz="2800" b="0" i="1" smtClean="0">
+                            <a:rPr lang="de-DE" sz="2000" b="0" i="1" smtClean="0">
                               <a:latin typeface="Cambria Math" panose="02040503050406030204" pitchFamily="18" charset="0"/>
                             </a:rPr>
                             <m:t>𝐿</m:t>
@@ -18694,13 +18694,13 @@
                         </m:e>
                         <m:sub>
                           <m:r>
-                            <a:rPr lang="de-DE" sz="2800" b="0" i="1" smtClean="0">
+                            <a:rPr lang="de-DE" sz="2000" b="0" i="1" smtClean="0">
                               <a:latin typeface="Cambria Math" panose="02040503050406030204" pitchFamily="18" charset="0"/>
                             </a:rPr>
                             <m:t>𝑢</m:t>
                           </m:r>
                           <m:r>
-                            <a:rPr lang="en-US" sz="2800" b="0" i="1" smtClean="0">
+                            <a:rPr lang="en-US" sz="2000" b="0" i="1" smtClean="0">
                               <a:latin typeface="Cambria Math" panose="02040503050406030204" pitchFamily="18" charset="0"/>
                             </a:rPr>
                             <m:t>12</m:t>
@@ -18710,7 +18710,7 @@
                     </m:oMath>
                   </m:oMathPara>
                 </a14:m>
-                <a:endParaRPr lang="en-US" sz="2800" dirty="0"/>
+                <a:endParaRPr lang="en-US" sz="2000" dirty="0"/>
               </a:p>
             </p:txBody>
           </p:sp>
@@ -18732,8 +18732,8 @@
             </p:nvSpPr>
             <p:spPr>
               <a:xfrm>
-                <a:off x="9509423" y="4850139"/>
-                <a:ext cx="938527" cy="523220"/>
+                <a:off x="9797649" y="5222974"/>
+                <a:ext cx="724301" cy="400110"/>
               </a:xfrm>
               <a:prstGeom prst="rect">
                 <a:avLst/>
@@ -18776,8 +18776,8 @@
             </p:nvSpPr>
             <p:spPr>
               <a:xfrm>
-                <a:off x="9711613" y="5923392"/>
-                <a:ext cx="925703" cy="523220"/>
+                <a:off x="9807267" y="6084022"/>
+                <a:ext cx="714683" cy="400110"/>
               </a:xfrm>
               <a:prstGeom prst="rect">
                 <a:avLst/>
@@ -18800,28 +18800,28 @@
                       <m:sSub>
                         <m:sSubPr>
                           <m:ctrlPr>
-                            <a:rPr lang="en-US" sz="2800" i="1" smtClean="0">
+                            <a:rPr lang="en-US" sz="2000" i="1" smtClean="0">
                               <a:latin typeface="Cambria Math" panose="02040503050406030204" pitchFamily="18" charset="0"/>
                             </a:rPr>
                           </m:ctrlPr>
                         </m:sSubPr>
                         <m:e>
                           <m:r>
-                            <a:rPr lang="de-DE" sz="2800" b="0" i="1" smtClean="0">
-                              <a:latin typeface="Cambria Math" panose="02040503050406030204" pitchFamily="18" charset="0"/>
-                            </a:rPr>
-                            <m:t>𝐿</m:t>
+                            <a:rPr lang="tr-TR" sz="2000" b="0" i="1" smtClean="0">
+                              <a:latin typeface="Cambria Math" panose="02040503050406030204" pitchFamily="18" charset="0"/>
+                            </a:rPr>
+                            <m:t>𝑃</m:t>
                           </m:r>
                         </m:e>
                         <m:sub>
                           <m:r>
-                            <a:rPr lang="de-DE" sz="2800" b="0" i="1" smtClean="0">
+                            <a:rPr lang="de-DE" sz="2000" b="0" i="1" smtClean="0">
                               <a:latin typeface="Cambria Math" panose="02040503050406030204" pitchFamily="18" charset="0"/>
                             </a:rPr>
                             <m:t>𝑏</m:t>
                           </m:r>
                           <m:r>
-                            <a:rPr lang="de-DE" sz="2800" b="0" i="1" smtClean="0">
+                            <a:rPr lang="de-DE" sz="2000" b="0" i="1" smtClean="0">
                               <a:latin typeface="Cambria Math" panose="02040503050406030204" pitchFamily="18" charset="0"/>
                             </a:rPr>
                             <m:t>12</m:t>
@@ -18831,7 +18831,7 @@
                     </m:oMath>
                   </m:oMathPara>
                 </a14:m>
-                <a:endParaRPr lang="en-US" sz="2800" dirty="0"/>
+                <a:endParaRPr lang="en-US" sz="2000" dirty="0"/>
               </a:p>
             </p:txBody>
           </p:sp>
@@ -18853,8 +18853,8 @@
             </p:nvSpPr>
             <p:spPr>
               <a:xfrm>
-                <a:off x="9711613" y="5923392"/>
-                <a:ext cx="925703" cy="523220"/>
+                <a:off x="9807267" y="6084022"/>
+                <a:ext cx="714683" cy="400110"/>
               </a:xfrm>
               <a:prstGeom prst="rect">
                 <a:avLst/>
@@ -18974,7 +18974,7 @@
             <p:spPr>
               <a:xfrm>
                 <a:off x="9050993" y="5620076"/>
-                <a:ext cx="594458" cy="369332"/>
+                <a:ext cx="639791" cy="400110"/>
               </a:xfrm>
               <a:prstGeom prst="rect">
                 <a:avLst/>
@@ -18987,6 +18987,7 @@
               </a:bodyPr>
               <a:lstStyle/>
               <a:p>
+                <a:pPr/>
                 <a14:m>
                   <m:oMathPara xmlns:m="http://schemas.openxmlformats.org/officeDocument/2006/math">
                     <m:oMathParaPr>
@@ -18994,7 +18995,7 @@
                     </m:oMathParaPr>
                     <m:oMath xmlns:m="http://schemas.openxmlformats.org/officeDocument/2006/math">
                       <m:r>
-                        <a:rPr lang="en-US" i="1" smtClean="0">
+                        <a:rPr lang="en-US" sz="2000" i="1" smtClean="0">
                           <a:latin typeface="Cambria Math" panose="02040503050406030204" pitchFamily="18" charset="0"/>
                           <a:ea typeface="Cambria Math" panose="02040503050406030204" pitchFamily="18" charset="0"/>
                         </a:rPr>
@@ -19003,7 +19004,7 @@
                       <m:sSub>
                         <m:sSubPr>
                           <m:ctrlPr>
-                            <a:rPr lang="en-US" i="1" smtClean="0">
+                            <a:rPr lang="en-US" sz="2000" i="1" smtClean="0">
                               <a:latin typeface="Cambria Math" panose="02040503050406030204" pitchFamily="18" charset="0"/>
                               <a:ea typeface="Cambria Math" panose="02040503050406030204" pitchFamily="18" charset="0"/>
                             </a:rPr>
@@ -19011,7 +19012,7 @@
                         </m:sSubPr>
                         <m:e>
                           <m:r>
-                            <a:rPr lang="en-US" b="0" i="1" smtClean="0">
+                            <a:rPr lang="en-US" sz="2000" b="0" i="1" smtClean="0">
                               <a:latin typeface="Cambria Math" panose="02040503050406030204" pitchFamily="18" charset="0"/>
                               <a:ea typeface="Cambria Math" panose="02040503050406030204" pitchFamily="18" charset="0"/>
                             </a:rPr>
@@ -19020,7 +19021,7 @@
                         </m:e>
                         <m:sub>
                           <m:r>
-                            <a:rPr lang="en-US" b="0" i="1" smtClean="0">
+                            <a:rPr lang="en-US" sz="2000" b="0" i="1" smtClean="0">
                               <a:latin typeface="Cambria Math" panose="02040503050406030204" pitchFamily="18" charset="0"/>
                               <a:ea typeface="Cambria Math" panose="02040503050406030204" pitchFamily="18" charset="0"/>
                             </a:rPr>
@@ -19031,7 +19032,7 @@
                     </m:oMath>
                   </m:oMathPara>
                 </a14:m>
-                <a:endParaRPr lang="en-US" dirty="0"/>
+                <a:endParaRPr lang="en-US" sz="2000" dirty="0"/>
               </a:p>
             </p:txBody>
           </p:sp>
@@ -19054,7 +19055,7 @@
             <p:spPr>
               <a:xfrm>
                 <a:off x="9050993" y="5620076"/>
-                <a:ext cx="594458" cy="369332"/>
+                <a:ext cx="639791" cy="400110"/>
               </a:xfrm>
               <a:prstGeom prst="rect">
                 <a:avLst/>
@@ -19098,7 +19099,7 @@
             <p:spPr>
               <a:xfrm>
                 <a:off x="8260721" y="5163839"/>
-                <a:ext cx="633250" cy="369332"/>
+                <a:ext cx="684162" cy="400110"/>
               </a:xfrm>
               <a:prstGeom prst="rect">
                 <a:avLst/>
@@ -19111,6 +19112,7 @@
               </a:bodyPr>
               <a:lstStyle/>
               <a:p>
+                <a:pPr/>
                 <a14:m>
                   <m:oMathPara xmlns:m="http://schemas.openxmlformats.org/officeDocument/2006/math">
                     <m:oMathParaPr>
@@ -19118,7 +19120,7 @@
                     </m:oMathParaPr>
                     <m:oMath xmlns:m="http://schemas.openxmlformats.org/officeDocument/2006/math">
                       <m:r>
-                        <a:rPr lang="en-US" i="1" smtClean="0">
+                        <a:rPr lang="en-US" sz="2000" i="1" smtClean="0">
                           <a:latin typeface="Cambria Math" panose="02040503050406030204" pitchFamily="18" charset="0"/>
                           <a:ea typeface="Cambria Math" panose="02040503050406030204" pitchFamily="18" charset="0"/>
                         </a:rPr>
@@ -19127,7 +19129,7 @@
                       <m:sSub>
                         <m:sSubPr>
                           <m:ctrlPr>
-                            <a:rPr lang="en-US" i="1" smtClean="0">
+                            <a:rPr lang="en-US" sz="2000" i="1" smtClean="0">
                               <a:latin typeface="Cambria Math" panose="02040503050406030204" pitchFamily="18" charset="0"/>
                               <a:ea typeface="Cambria Math" panose="02040503050406030204" pitchFamily="18" charset="0"/>
                             </a:rPr>
@@ -19135,7 +19137,7 @@
                         </m:sSubPr>
                         <m:e>
                           <m:r>
-                            <a:rPr lang="en-US" b="0" i="1" smtClean="0">
+                            <a:rPr lang="en-US" sz="2000" b="0" i="1" smtClean="0">
                               <a:latin typeface="Cambria Math" panose="02040503050406030204" pitchFamily="18" charset="0"/>
                               <a:ea typeface="Cambria Math" panose="02040503050406030204" pitchFamily="18" charset="0"/>
                             </a:rPr>
@@ -19144,7 +19146,7 @@
                         </m:e>
                         <m:sub>
                           <m:r>
-                            <a:rPr lang="en-US" b="0" i="1" smtClean="0">
+                            <a:rPr lang="en-US" sz="2000" b="0" i="1" smtClean="0">
                               <a:latin typeface="Cambria Math" panose="02040503050406030204" pitchFamily="18" charset="0"/>
                               <a:ea typeface="Cambria Math" panose="02040503050406030204" pitchFamily="18" charset="0"/>
                             </a:rPr>
@@ -19155,7 +19157,7 @@
                     </m:oMath>
                   </m:oMathPara>
                 </a14:m>
-                <a:endParaRPr lang="en-US" dirty="0"/>
+                <a:endParaRPr lang="en-US" sz="2000" dirty="0"/>
               </a:p>
             </p:txBody>
           </p:sp>
@@ -19178,7 +19180,7 @@
             <p:spPr>
               <a:xfrm>
                 <a:off x="8260721" y="5163839"/>
-                <a:ext cx="633250" cy="369332"/>
+                <a:ext cx="684162" cy="400110"/>
               </a:xfrm>
               <a:prstGeom prst="rect">
                 <a:avLst/>
@@ -19220,7 +19222,7 @@
         <p:spPr>
           <a:xfrm>
             <a:off x="4972050" y="2099000"/>
-            <a:ext cx="1623551" cy="1681621"/>
+            <a:ext cx="1780366" cy="2004998"/>
           </a:xfrm>
           <a:prstGeom prst="rect">
             <a:avLst/>
@@ -19251,7 +19253,7 @@
           <a:lstStyle/>
           <a:p>
             <a:pPr algn="ctr"/>
-            <a:endParaRPr lang="en-US"/>
+            <a:endParaRPr lang="en-US" sz="2000"/>
           </a:p>
         </p:txBody>
       </p:sp>
@@ -19264,18 +19266,777 @@
               </a:ext>
             </a:extLst>
           </p:cNvPr>
-          <p:cNvCxnSpPr/>
+          <p:cNvCxnSpPr>
+            <a:cxnSpLocks/>
+          </p:cNvCxnSpPr>
           <p:nvPr/>
         </p:nvCxnSpPr>
         <p:spPr>
           <a:xfrm>
-            <a:off x="6617970" y="3714420"/>
-            <a:ext cx="1280160" cy="1157718"/>
+            <a:off x="6830260" y="4125100"/>
+            <a:ext cx="1067870" cy="747038"/>
           </a:xfrm>
           <a:prstGeom prst="straightConnector1">
             <a:avLst/>
           </a:prstGeom>
           <a:ln w="25400">
+            <a:tailEnd type="triangle" w="lg" len="lg"/>
+          </a:ln>
+        </p:spPr>
+        <p:style>
+          <a:lnRef idx="2">
+            <a:schemeClr val="accent1"/>
+          </a:lnRef>
+          <a:fillRef idx="0">
+            <a:schemeClr val="accent1"/>
+          </a:fillRef>
+          <a:effectRef idx="1">
+            <a:schemeClr val="accent1"/>
+          </a:effectRef>
+          <a:fontRef idx="minor">
+            <a:schemeClr val="tx1"/>
+          </a:fontRef>
+        </p:style>
+      </p:cxnSp>
+      <p:cxnSp>
+        <p:nvCxnSpPr>
+          <p:cNvPr id="12" name="Straight Connector 11">
+            <a:extLst>
+              <a:ext uri="{FF2B5EF4-FFF2-40B4-BE49-F238E27FC236}">
+                <a16:creationId xmlns:a16="http://schemas.microsoft.com/office/drawing/2014/main" id="{5D11E6CA-4F46-3F84-818C-02A64745552D}"/>
+              </a:ext>
+            </a:extLst>
+          </p:cNvPr>
+          <p:cNvCxnSpPr>
+            <a:cxnSpLocks/>
+          </p:cNvCxnSpPr>
+          <p:nvPr/>
+        </p:nvCxnSpPr>
+        <p:spPr>
+          <a:xfrm>
+            <a:off x="6160849" y="2911882"/>
+            <a:ext cx="2925762" cy="13033"/>
+          </a:xfrm>
+          <a:prstGeom prst="line">
+            <a:avLst/>
+          </a:prstGeom>
+        </p:spPr>
+        <p:style>
+          <a:lnRef idx="2">
+            <a:schemeClr val="accent1"/>
+          </a:lnRef>
+          <a:fillRef idx="0">
+            <a:schemeClr val="accent1"/>
+          </a:fillRef>
+          <a:effectRef idx="1">
+            <a:schemeClr val="accent1"/>
+          </a:effectRef>
+          <a:fontRef idx="minor">
+            <a:schemeClr val="tx1"/>
+          </a:fontRef>
+        </p:style>
+      </p:cxnSp>
+      <p:cxnSp>
+        <p:nvCxnSpPr>
+          <p:cNvPr id="55" name="Straight Connector 54">
+            <a:extLst>
+              <a:ext uri="{FF2B5EF4-FFF2-40B4-BE49-F238E27FC236}">
+                <a16:creationId xmlns:a16="http://schemas.microsoft.com/office/drawing/2014/main" id="{7763C115-F4AF-EC08-D7A2-189449DDA07C}"/>
+              </a:ext>
+            </a:extLst>
+          </p:cNvPr>
+          <p:cNvCxnSpPr>
+            <a:cxnSpLocks/>
+          </p:cNvCxnSpPr>
+          <p:nvPr/>
+        </p:nvCxnSpPr>
+        <p:spPr>
+          <a:xfrm>
+            <a:off x="5682375" y="2646798"/>
+            <a:ext cx="495991" cy="269547"/>
+          </a:xfrm>
+          <a:prstGeom prst="line">
+            <a:avLst/>
+          </a:prstGeom>
+        </p:spPr>
+        <p:style>
+          <a:lnRef idx="2">
+            <a:schemeClr val="accent1"/>
+          </a:lnRef>
+          <a:fillRef idx="0">
+            <a:schemeClr val="accent1"/>
+          </a:fillRef>
+          <a:effectRef idx="1">
+            <a:schemeClr val="accent1"/>
+          </a:effectRef>
+          <a:fontRef idx="minor">
+            <a:schemeClr val="tx1"/>
+          </a:fontRef>
+        </p:style>
+      </p:cxnSp>
+      <mc:AlternateContent xmlns:mc="http://schemas.openxmlformats.org/markup-compatibility/2006">
+        <mc:Choice xmlns:a14="http://schemas.microsoft.com/office/drawing/2010/main" Requires="a14">
+          <p:sp>
+            <p:nvSpPr>
+              <p:cNvPr id="61" name="TextBox 60">
+                <a:extLst>
+                  <a:ext uri="{FF2B5EF4-FFF2-40B4-BE49-F238E27FC236}">
+                    <a16:creationId xmlns:a16="http://schemas.microsoft.com/office/drawing/2014/main" id="{D3EE2C48-1364-CA41-94F9-DDF786F963D0}"/>
+                  </a:ext>
+                </a:extLst>
+              </p:cNvPr>
+              <p:cNvSpPr txBox="1"/>
+              <p:nvPr/>
+            </p:nvSpPr>
+            <p:spPr>
+              <a:xfrm>
+                <a:off x="5935631" y="2430946"/>
+                <a:ext cx="719171" cy="400110"/>
+              </a:xfrm>
+              <a:prstGeom prst="rect">
+                <a:avLst/>
+              </a:prstGeom>
+              <a:noFill/>
+            </p:spPr>
+            <p:txBody>
+              <a:bodyPr wrap="none" rtlCol="0">
+                <a:spAutoFit/>
+              </a:bodyPr>
+              <a:lstStyle/>
+              <a:p>
+                <a:pPr/>
+                <a14:m>
+                  <m:oMathPara xmlns:m="http://schemas.openxmlformats.org/officeDocument/2006/math">
+                    <m:oMathParaPr>
+                      <m:jc m:val="centerGroup"/>
+                    </m:oMathParaPr>
+                    <m:oMath xmlns:m="http://schemas.openxmlformats.org/officeDocument/2006/math">
+                      <m:sSub>
+                        <m:sSubPr>
+                          <m:ctrlPr>
+                            <a:rPr lang="en-US" sz="2000" i="1" smtClean="0">
+                              <a:latin typeface="Cambria Math" panose="02040503050406030204" pitchFamily="18" charset="0"/>
+                            </a:rPr>
+                          </m:ctrlPr>
+                        </m:sSubPr>
+                        <m:e>
+                          <m:r>
+                            <a:rPr lang="tr-TR" sz="2000" b="0" i="1" smtClean="0">
+                              <a:latin typeface="Cambria Math" panose="02040503050406030204" pitchFamily="18" charset="0"/>
+                            </a:rPr>
+                            <m:t>𝑃</m:t>
+                          </m:r>
+                        </m:e>
+                        <m:sub>
+                          <m:r>
+                            <a:rPr lang="de-DE" sz="2000" b="0" i="1" smtClean="0">
+                              <a:latin typeface="Cambria Math" panose="02040503050406030204" pitchFamily="18" charset="0"/>
+                            </a:rPr>
+                            <m:t>𝑢</m:t>
+                          </m:r>
+                          <m:r>
+                            <a:rPr lang="en-US" sz="2000" b="0" i="1" smtClean="0">
+                              <a:latin typeface="Cambria Math" panose="02040503050406030204" pitchFamily="18" charset="0"/>
+                            </a:rPr>
+                            <m:t>12</m:t>
+                          </m:r>
+                        </m:sub>
+                      </m:sSub>
+                    </m:oMath>
+                  </m:oMathPara>
+                </a14:m>
+                <a:endParaRPr lang="en-US" sz="2000" dirty="0"/>
+              </a:p>
+            </p:txBody>
+          </p:sp>
+        </mc:Choice>
+        <mc:Fallback>
+          <p:sp>
+            <p:nvSpPr>
+              <p:cNvPr id="61" name="TextBox 60">
+                <a:extLst>
+                  <a:ext uri="{FF2B5EF4-FFF2-40B4-BE49-F238E27FC236}">
+                    <a16:creationId xmlns:a16="http://schemas.microsoft.com/office/drawing/2014/main" id="{D3EE2C48-1364-CA41-94F9-DDF786F963D0}"/>
+                  </a:ext>
+                </a:extLst>
+              </p:cNvPr>
+              <p:cNvSpPr txBox="1">
+                <a:spLocks noRot="1" noChangeAspect="1" noMove="1" noResize="1" noEditPoints="1" noAdjustHandles="1" noChangeArrowheads="1" noChangeShapeType="1" noTextEdit="1"/>
+              </p:cNvSpPr>
+              <p:nvPr/>
+            </p:nvSpPr>
+            <p:spPr>
+              <a:xfrm>
+                <a:off x="5935631" y="2430946"/>
+                <a:ext cx="719171" cy="400110"/>
+              </a:xfrm>
+              <a:prstGeom prst="rect">
+                <a:avLst/>
+              </a:prstGeom>
+              <a:blipFill>
+                <a:blip r:embed="rId34"/>
+                <a:stretch>
+                  <a:fillRect/>
+                </a:stretch>
+              </a:blipFill>
+            </p:spPr>
+            <p:txBody>
+              <a:bodyPr/>
+              <a:lstStyle/>
+              <a:p>
+                <a:r>
+                  <a:rPr lang="en-US">
+                    <a:noFill/>
+                  </a:rPr>
+                  <a:t> </a:t>
+                </a:r>
+              </a:p>
+            </p:txBody>
+          </p:sp>
+        </mc:Fallback>
+      </mc:AlternateContent>
+      <p:cxnSp>
+        <p:nvCxnSpPr>
+          <p:cNvPr id="72" name="Straight Connector 71">
+            <a:extLst>
+              <a:ext uri="{FF2B5EF4-FFF2-40B4-BE49-F238E27FC236}">
+                <a16:creationId xmlns:a16="http://schemas.microsoft.com/office/drawing/2014/main" id="{85624E51-C6B3-A19D-470F-18B05C0E60ED}"/>
+              </a:ext>
+            </a:extLst>
+          </p:cNvPr>
+          <p:cNvCxnSpPr>
+            <a:cxnSpLocks/>
+          </p:cNvCxnSpPr>
+          <p:nvPr/>
+        </p:nvCxnSpPr>
+        <p:spPr>
+          <a:xfrm>
+            <a:off x="6125231" y="3422483"/>
+            <a:ext cx="2279629" cy="13166"/>
+          </a:xfrm>
+          <a:prstGeom prst="line">
+            <a:avLst/>
+          </a:prstGeom>
+        </p:spPr>
+        <p:style>
+          <a:lnRef idx="2">
+            <a:schemeClr val="accent1"/>
+          </a:lnRef>
+          <a:fillRef idx="0">
+            <a:schemeClr val="accent1"/>
+          </a:fillRef>
+          <a:effectRef idx="1">
+            <a:schemeClr val="accent1"/>
+          </a:effectRef>
+          <a:fontRef idx="minor">
+            <a:schemeClr val="tx1"/>
+          </a:fontRef>
+        </p:style>
+      </p:cxnSp>
+      <p:cxnSp>
+        <p:nvCxnSpPr>
+          <p:cNvPr id="77" name="Straight Connector 76">
+            <a:extLst>
+              <a:ext uri="{FF2B5EF4-FFF2-40B4-BE49-F238E27FC236}">
+                <a16:creationId xmlns:a16="http://schemas.microsoft.com/office/drawing/2014/main" id="{940408BC-8B4E-B7BA-09FF-F05054BD319A}"/>
+              </a:ext>
+            </a:extLst>
+          </p:cNvPr>
+          <p:cNvCxnSpPr>
+            <a:cxnSpLocks/>
+          </p:cNvCxnSpPr>
+          <p:nvPr/>
+        </p:nvCxnSpPr>
+        <p:spPr>
+          <a:xfrm>
+            <a:off x="5646757" y="3157399"/>
+            <a:ext cx="495991" cy="269547"/>
+          </a:xfrm>
+          <a:prstGeom prst="line">
+            <a:avLst/>
+          </a:prstGeom>
+        </p:spPr>
+        <p:style>
+          <a:lnRef idx="2">
+            <a:schemeClr val="accent1"/>
+          </a:lnRef>
+          <a:fillRef idx="0">
+            <a:schemeClr val="accent1"/>
+          </a:fillRef>
+          <a:effectRef idx="1">
+            <a:schemeClr val="accent1"/>
+          </a:effectRef>
+          <a:fontRef idx="minor">
+            <a:schemeClr val="tx1"/>
+          </a:fontRef>
+        </p:style>
+      </p:cxnSp>
+      <mc:AlternateContent xmlns:mc="http://schemas.openxmlformats.org/markup-compatibility/2006">
+        <mc:Choice xmlns:a14="http://schemas.microsoft.com/office/drawing/2010/main" Requires="a14">
+          <p:sp>
+            <p:nvSpPr>
+              <p:cNvPr id="84" name="TextBox 83">
+                <a:extLst>
+                  <a:ext uri="{FF2B5EF4-FFF2-40B4-BE49-F238E27FC236}">
+                    <a16:creationId xmlns:a16="http://schemas.microsoft.com/office/drawing/2014/main" id="{5105571E-D423-51D6-9834-69C088C4B7E1}"/>
+                  </a:ext>
+                </a:extLst>
+              </p:cNvPr>
+              <p:cNvSpPr txBox="1"/>
+              <p:nvPr/>
+            </p:nvSpPr>
+            <p:spPr>
+              <a:xfrm>
+                <a:off x="6032951" y="3425345"/>
+                <a:ext cx="714683" cy="400110"/>
+              </a:xfrm>
+              <a:prstGeom prst="rect">
+                <a:avLst/>
+              </a:prstGeom>
+              <a:noFill/>
+            </p:spPr>
+            <p:txBody>
+              <a:bodyPr wrap="none" rtlCol="0">
+                <a:spAutoFit/>
+              </a:bodyPr>
+              <a:lstStyle/>
+              <a:p>
+                <a:pPr/>
+                <a14:m>
+                  <m:oMathPara xmlns:m="http://schemas.openxmlformats.org/officeDocument/2006/math">
+                    <m:oMathParaPr>
+                      <m:jc m:val="centerGroup"/>
+                    </m:oMathParaPr>
+                    <m:oMath xmlns:m="http://schemas.openxmlformats.org/officeDocument/2006/math">
+                      <m:sSub>
+                        <m:sSubPr>
+                          <m:ctrlPr>
+                            <a:rPr lang="en-US" sz="2000" i="1" smtClean="0">
+                              <a:latin typeface="Cambria Math" panose="02040503050406030204" pitchFamily="18" charset="0"/>
+                            </a:rPr>
+                          </m:ctrlPr>
+                        </m:sSubPr>
+                        <m:e>
+                          <m:r>
+                            <a:rPr lang="tr-TR" sz="2000" b="0" i="1" smtClean="0">
+                              <a:latin typeface="Cambria Math" panose="02040503050406030204" pitchFamily="18" charset="0"/>
+                            </a:rPr>
+                            <m:t>𝑃</m:t>
+                          </m:r>
+                        </m:e>
+                        <m:sub>
+                          <m:r>
+                            <a:rPr lang="de-DE" sz="2000" b="0" i="1" smtClean="0">
+                              <a:latin typeface="Cambria Math" panose="02040503050406030204" pitchFamily="18" charset="0"/>
+                            </a:rPr>
+                            <m:t>𝑏</m:t>
+                          </m:r>
+                          <m:r>
+                            <a:rPr lang="de-DE" sz="2000" b="0" i="1" smtClean="0">
+                              <a:latin typeface="Cambria Math" panose="02040503050406030204" pitchFamily="18" charset="0"/>
+                            </a:rPr>
+                            <m:t>12</m:t>
+                          </m:r>
+                        </m:sub>
+                      </m:sSub>
+                    </m:oMath>
+                  </m:oMathPara>
+                </a14:m>
+                <a:endParaRPr lang="en-US" sz="2000" dirty="0"/>
+              </a:p>
+            </p:txBody>
+          </p:sp>
+        </mc:Choice>
+        <mc:Fallback>
+          <p:sp>
+            <p:nvSpPr>
+              <p:cNvPr id="84" name="TextBox 83">
+                <a:extLst>
+                  <a:ext uri="{FF2B5EF4-FFF2-40B4-BE49-F238E27FC236}">
+                    <a16:creationId xmlns:a16="http://schemas.microsoft.com/office/drawing/2014/main" id="{5105571E-D423-51D6-9834-69C088C4B7E1}"/>
+                  </a:ext>
+                </a:extLst>
+              </p:cNvPr>
+              <p:cNvSpPr txBox="1">
+                <a:spLocks noRot="1" noChangeAspect="1" noMove="1" noResize="1" noEditPoints="1" noAdjustHandles="1" noChangeArrowheads="1" noChangeShapeType="1" noTextEdit="1"/>
+              </p:cNvSpPr>
+              <p:nvPr/>
+            </p:nvSpPr>
+            <p:spPr>
+              <a:xfrm>
+                <a:off x="6032951" y="3425345"/>
+                <a:ext cx="714683" cy="400110"/>
+              </a:xfrm>
+              <a:prstGeom prst="rect">
+                <a:avLst/>
+              </a:prstGeom>
+              <a:blipFill>
+                <a:blip r:embed="rId35"/>
+                <a:stretch>
+                  <a:fillRect/>
+                </a:stretch>
+              </a:blipFill>
+            </p:spPr>
+            <p:txBody>
+              <a:bodyPr/>
+              <a:lstStyle/>
+              <a:p>
+                <a:r>
+                  <a:rPr lang="en-US">
+                    <a:noFill/>
+                  </a:rPr>
+                  <a:t> </a:t>
+                </a:r>
+              </a:p>
+            </p:txBody>
+          </p:sp>
+        </mc:Fallback>
+      </mc:AlternateContent>
+      <p:cxnSp>
+        <p:nvCxnSpPr>
+          <p:cNvPr id="104" name="Straight Connector 103">
+            <a:extLst>
+              <a:ext uri="{FF2B5EF4-FFF2-40B4-BE49-F238E27FC236}">
+                <a16:creationId xmlns:a16="http://schemas.microsoft.com/office/drawing/2014/main" id="{C170A836-5860-103F-58A6-863D9A598F68}"/>
+              </a:ext>
+            </a:extLst>
+          </p:cNvPr>
+          <p:cNvCxnSpPr>
+            <a:cxnSpLocks/>
+          </p:cNvCxnSpPr>
+          <p:nvPr/>
+        </p:nvCxnSpPr>
+        <p:spPr>
+          <a:xfrm>
+            <a:off x="10374144" y="3034057"/>
+            <a:ext cx="0" cy="195926"/>
+          </a:xfrm>
+          <a:prstGeom prst="line">
+            <a:avLst/>
+          </a:prstGeom>
+        </p:spPr>
+        <p:style>
+          <a:lnRef idx="2">
+            <a:schemeClr val="accent1"/>
+          </a:lnRef>
+          <a:fillRef idx="0">
+            <a:schemeClr val="accent1"/>
+          </a:fillRef>
+          <a:effectRef idx="1">
+            <a:schemeClr val="accent1"/>
+          </a:effectRef>
+          <a:fontRef idx="minor">
+            <a:schemeClr val="tx1"/>
+          </a:fontRef>
+        </p:style>
+      </p:cxnSp>
+      <mc:AlternateContent xmlns:mc="http://schemas.openxmlformats.org/markup-compatibility/2006">
+        <mc:Choice xmlns:a14="http://schemas.microsoft.com/office/drawing/2010/main" Requires="a14">
+          <p:sp>
+            <p:nvSpPr>
+              <p:cNvPr id="107" name="TextBox 106">
+                <a:extLst>
+                  <a:ext uri="{FF2B5EF4-FFF2-40B4-BE49-F238E27FC236}">
+                    <a16:creationId xmlns:a16="http://schemas.microsoft.com/office/drawing/2014/main" id="{72154ABC-67F1-5E52-A134-4BCC70CD63E9}"/>
+                  </a:ext>
+                </a:extLst>
+              </p:cNvPr>
+              <p:cNvSpPr txBox="1"/>
+              <p:nvPr/>
+            </p:nvSpPr>
+            <p:spPr>
+              <a:xfrm>
+                <a:off x="10762395" y="2393901"/>
+                <a:ext cx="719171" cy="400110"/>
+              </a:xfrm>
+              <a:prstGeom prst="rect">
+                <a:avLst/>
+              </a:prstGeom>
+              <a:noFill/>
+            </p:spPr>
+            <p:txBody>
+              <a:bodyPr wrap="none" rtlCol="0">
+                <a:spAutoFit/>
+              </a:bodyPr>
+              <a:lstStyle/>
+              <a:p>
+                <a:pPr/>
+                <a14:m>
+                  <m:oMathPara xmlns:m="http://schemas.openxmlformats.org/officeDocument/2006/math">
+                    <m:oMathParaPr>
+                      <m:jc m:val="centerGroup"/>
+                    </m:oMathParaPr>
+                    <m:oMath xmlns:m="http://schemas.openxmlformats.org/officeDocument/2006/math">
+                      <m:sSub>
+                        <m:sSubPr>
+                          <m:ctrlPr>
+                            <a:rPr lang="en-US" sz="2000" i="1" smtClean="0">
+                              <a:latin typeface="Cambria Math" panose="02040503050406030204" pitchFamily="18" charset="0"/>
+                            </a:rPr>
+                          </m:ctrlPr>
+                        </m:sSubPr>
+                        <m:e>
+                          <m:r>
+                            <a:rPr lang="en-US" sz="2000" b="0" i="1" smtClean="0">
+                              <a:latin typeface="Cambria Math" panose="02040503050406030204" pitchFamily="18" charset="0"/>
+                            </a:rPr>
+                            <m:t>𝑃</m:t>
+                          </m:r>
+                        </m:e>
+                        <m:sub>
+                          <m:r>
+                            <a:rPr lang="en-US" sz="2000" b="0" i="1" smtClean="0">
+                              <a:latin typeface="Cambria Math" panose="02040503050406030204" pitchFamily="18" charset="0"/>
+                            </a:rPr>
+                            <m:t>𝑢</m:t>
+                          </m:r>
+                          <m:r>
+                            <a:rPr lang="tr-TR" sz="2000" b="0" i="1" smtClean="0">
+                              <a:latin typeface="Cambria Math" panose="02040503050406030204" pitchFamily="18" charset="0"/>
+                            </a:rPr>
+                            <m:t>11</m:t>
+                          </m:r>
+                        </m:sub>
+                      </m:sSub>
+                    </m:oMath>
+                  </m:oMathPara>
+                </a14:m>
+                <a:endParaRPr lang="en-US" sz="2000" dirty="0"/>
+              </a:p>
+            </p:txBody>
+          </p:sp>
+        </mc:Choice>
+        <mc:Fallback>
+          <p:sp>
+            <p:nvSpPr>
+              <p:cNvPr id="107" name="TextBox 106">
+                <a:extLst>
+                  <a:ext uri="{FF2B5EF4-FFF2-40B4-BE49-F238E27FC236}">
+                    <a16:creationId xmlns:a16="http://schemas.microsoft.com/office/drawing/2014/main" id="{72154ABC-67F1-5E52-A134-4BCC70CD63E9}"/>
+                  </a:ext>
+                </a:extLst>
+              </p:cNvPr>
+              <p:cNvSpPr txBox="1">
+                <a:spLocks noRot="1" noChangeAspect="1" noMove="1" noResize="1" noEditPoints="1" noAdjustHandles="1" noChangeArrowheads="1" noChangeShapeType="1" noTextEdit="1"/>
+              </p:cNvSpPr>
+              <p:nvPr/>
+            </p:nvSpPr>
+            <p:spPr>
+              <a:xfrm>
+                <a:off x="10762395" y="2393901"/>
+                <a:ext cx="719171" cy="400110"/>
+              </a:xfrm>
+              <a:prstGeom prst="rect">
+                <a:avLst/>
+              </a:prstGeom>
+              <a:blipFill>
+                <a:blip r:embed="rId36"/>
+                <a:stretch>
+                  <a:fillRect/>
+                </a:stretch>
+              </a:blipFill>
+            </p:spPr>
+            <p:txBody>
+              <a:bodyPr/>
+              <a:lstStyle/>
+              <a:p>
+                <a:r>
+                  <a:rPr lang="en-US">
+                    <a:noFill/>
+                  </a:rPr>
+                  <a:t> </a:t>
+                </a:r>
+              </a:p>
+            </p:txBody>
+          </p:sp>
+        </mc:Fallback>
+      </mc:AlternateContent>
+      <p:cxnSp>
+        <p:nvCxnSpPr>
+          <p:cNvPr id="108" name="Straight Arrow Connector 107">
+            <a:extLst>
+              <a:ext uri="{FF2B5EF4-FFF2-40B4-BE49-F238E27FC236}">
+                <a16:creationId xmlns:a16="http://schemas.microsoft.com/office/drawing/2014/main" id="{F98447C8-D35D-1369-C43E-D383FBC4CA2C}"/>
+              </a:ext>
+            </a:extLst>
+          </p:cNvPr>
+          <p:cNvCxnSpPr>
+            <a:cxnSpLocks/>
+          </p:cNvCxnSpPr>
+          <p:nvPr/>
+        </p:nvCxnSpPr>
+        <p:spPr>
+          <a:xfrm flipH="1">
+            <a:off x="10434877" y="2805485"/>
+            <a:ext cx="346980" cy="240610"/>
+          </a:xfrm>
+          <a:prstGeom prst="straightConnector1">
+            <a:avLst/>
+          </a:prstGeom>
+          <a:ln>
+            <a:tailEnd type="triangle" w="lg" len="lg"/>
+          </a:ln>
+        </p:spPr>
+        <p:style>
+          <a:lnRef idx="2">
+            <a:schemeClr val="accent1"/>
+          </a:lnRef>
+          <a:fillRef idx="0">
+            <a:schemeClr val="accent1"/>
+          </a:fillRef>
+          <a:effectRef idx="1">
+            <a:schemeClr val="accent1"/>
+          </a:effectRef>
+          <a:fontRef idx="minor">
+            <a:schemeClr val="tx1"/>
+          </a:fontRef>
+        </p:style>
+      </p:cxnSp>
+      <mc:AlternateContent xmlns:mc="http://schemas.openxmlformats.org/markup-compatibility/2006">
+        <mc:Choice xmlns:a14="http://schemas.microsoft.com/office/drawing/2010/main" Requires="a14">
+          <p:sp>
+            <p:nvSpPr>
+              <p:cNvPr id="111" name="TextBox 110">
+                <a:extLst>
+                  <a:ext uri="{FF2B5EF4-FFF2-40B4-BE49-F238E27FC236}">
+                    <a16:creationId xmlns:a16="http://schemas.microsoft.com/office/drawing/2014/main" id="{0FCD48F5-C883-5BB6-F2D3-D07DBBD434A6}"/>
+                  </a:ext>
+                </a:extLst>
+              </p:cNvPr>
+              <p:cNvSpPr txBox="1"/>
+              <p:nvPr/>
+            </p:nvSpPr>
+            <p:spPr>
+              <a:xfrm>
+                <a:off x="10761278" y="3252646"/>
+                <a:ext cx="709553" cy="400110"/>
+              </a:xfrm>
+              <a:prstGeom prst="rect">
+                <a:avLst/>
+              </a:prstGeom>
+              <a:noFill/>
+            </p:spPr>
+            <p:txBody>
+              <a:bodyPr wrap="none" rtlCol="0">
+                <a:spAutoFit/>
+              </a:bodyPr>
+              <a:lstStyle/>
+              <a:p>
+                <a:pPr/>
+                <a14:m>
+                  <m:oMathPara xmlns:m="http://schemas.openxmlformats.org/officeDocument/2006/math">
+                    <m:oMathParaPr>
+                      <m:jc m:val="centerGroup"/>
+                    </m:oMathParaPr>
+                    <m:oMath xmlns:m="http://schemas.openxmlformats.org/officeDocument/2006/math">
+                      <m:sSub>
+                        <m:sSubPr>
+                          <m:ctrlPr>
+                            <a:rPr lang="en-US" sz="2000" i="1" smtClean="0">
+                              <a:latin typeface="Cambria Math" panose="02040503050406030204" pitchFamily="18" charset="0"/>
+                            </a:rPr>
+                          </m:ctrlPr>
+                        </m:sSubPr>
+                        <m:e>
+                          <m:r>
+                            <a:rPr lang="en-US" sz="2000" b="0" i="1" smtClean="0">
+                              <a:latin typeface="Cambria Math" panose="02040503050406030204" pitchFamily="18" charset="0"/>
+                            </a:rPr>
+                            <m:t>𝑃</m:t>
+                          </m:r>
+                        </m:e>
+                        <m:sub>
+                          <m:r>
+                            <a:rPr lang="tr-TR" sz="2000" b="0" i="1" smtClean="0">
+                              <a:latin typeface="Cambria Math" panose="02040503050406030204" pitchFamily="18" charset="0"/>
+                            </a:rPr>
+                            <m:t>𝑏</m:t>
+                          </m:r>
+                          <m:r>
+                            <a:rPr lang="tr-TR" sz="2000" b="0" i="1" smtClean="0">
+                              <a:latin typeface="Cambria Math" panose="02040503050406030204" pitchFamily="18" charset="0"/>
+                            </a:rPr>
+                            <m:t>11</m:t>
+                          </m:r>
+                        </m:sub>
+                      </m:sSub>
+                    </m:oMath>
+                  </m:oMathPara>
+                </a14:m>
+                <a:endParaRPr lang="en-US" sz="2000" dirty="0"/>
+              </a:p>
+            </p:txBody>
+          </p:sp>
+        </mc:Choice>
+        <mc:Fallback>
+          <p:sp>
+            <p:nvSpPr>
+              <p:cNvPr id="111" name="TextBox 110">
+                <a:extLst>
+                  <a:ext uri="{FF2B5EF4-FFF2-40B4-BE49-F238E27FC236}">
+                    <a16:creationId xmlns:a16="http://schemas.microsoft.com/office/drawing/2014/main" id="{0FCD48F5-C883-5BB6-F2D3-D07DBBD434A6}"/>
+                  </a:ext>
+                </a:extLst>
+              </p:cNvPr>
+              <p:cNvSpPr txBox="1">
+                <a:spLocks noRot="1" noChangeAspect="1" noMove="1" noResize="1" noEditPoints="1" noAdjustHandles="1" noChangeArrowheads="1" noChangeShapeType="1" noTextEdit="1"/>
+              </p:cNvSpPr>
+              <p:nvPr/>
+            </p:nvSpPr>
+            <p:spPr>
+              <a:xfrm>
+                <a:off x="10761278" y="3252646"/>
+                <a:ext cx="709553" cy="400110"/>
+              </a:xfrm>
+              <a:prstGeom prst="rect">
+                <a:avLst/>
+              </a:prstGeom>
+              <a:blipFill>
+                <a:blip r:embed="rId37"/>
+                <a:stretch>
+                  <a:fillRect b="-1538"/>
+                </a:stretch>
+              </a:blipFill>
+            </p:spPr>
+            <p:txBody>
+              <a:bodyPr/>
+              <a:lstStyle/>
+              <a:p>
+                <a:r>
+                  <a:rPr lang="en-US">
+                    <a:noFill/>
+                  </a:rPr>
+                  <a:t> </a:t>
+                </a:r>
+              </a:p>
+            </p:txBody>
+          </p:sp>
+        </mc:Fallback>
+      </mc:AlternateContent>
+      <p:cxnSp>
+        <p:nvCxnSpPr>
+          <p:cNvPr id="118" name="Straight Arrow Connector 117">
+            <a:extLst>
+              <a:ext uri="{FF2B5EF4-FFF2-40B4-BE49-F238E27FC236}">
+                <a16:creationId xmlns:a16="http://schemas.microsoft.com/office/drawing/2014/main" id="{FCA54062-948D-0526-9B60-4959C1B5FA16}"/>
+              </a:ext>
+            </a:extLst>
+          </p:cNvPr>
+          <p:cNvCxnSpPr>
+            <a:cxnSpLocks/>
+            <a:stCxn id="111" idx="1"/>
+          </p:cNvCxnSpPr>
+          <p:nvPr/>
+        </p:nvCxnSpPr>
+        <p:spPr>
+          <a:xfrm flipH="1" flipV="1">
+            <a:off x="10426296" y="3271081"/>
+            <a:ext cx="334982" cy="181620"/>
+          </a:xfrm>
+          <a:prstGeom prst="straightConnector1">
+            <a:avLst/>
+          </a:prstGeom>
+          <a:ln>
             <a:tailEnd type="triangle" w="lg" len="lg"/>
           </a:ln>
         </p:spPr>
@@ -19304,13 +20065,13 @@
   <p:clrMapOvr>
     <a:masterClrMapping/>
   </p:clrMapOvr>
-  <mc:AlternateContent xmlns:mc="http://schemas.openxmlformats.org/markup-compatibility/2006">
-    <mc:Choice xmlns:p14="http://schemas.microsoft.com/office/powerpoint/2010/main" Requires="p14">
+  <mc:AlternateContent xmlns:mc="http://schemas.openxmlformats.org/markup-compatibility/2006" xmlns:p14="http://schemas.microsoft.com/office/powerpoint/2010/main">
+    <mc:Choice Requires="p14">
       <p:transition spd="med" p14:dur="700">
         <p:fade/>
       </p:transition>
     </mc:Choice>
-    <mc:Fallback>
+    <mc:Fallback xmlns="">
       <p:transition spd="med">
         <p:fade/>
       </p:transition>

</xml_diff>